<commit_message>
feat(project-06): finalize 100% complete implementation, models, tests, docs, PPT, and video demonstration for PROJECT-006
</commit_message>
<xml_diff>
--- a/project_06_child_gait_prediction/presentations/project_presentation.pptx
+++ b/project_06_child_gait_prediction/presentations/project_presentation.pptx
@@ -13,6 +13,13 @@
     <p:sldId id="261" r:id="rId12"/>
     <p:sldId id="262" r:id="rId13"/>
     <p:sldId id="263" r:id="rId14"/>
+    <p:sldId id="264" r:id="rId15"/>
+    <p:sldId id="265" r:id="rId16"/>
+    <p:sldId id="266" r:id="rId17"/>
+    <p:sldId id="267" r:id="rId18"/>
+    <p:sldId id="268" r:id="rId19"/>
+    <p:sldId id="269" r:id="rId20"/>
+    <p:sldId id="270" r:id="rId21"/>
   </p:sldIdLst>
   <p:sldSz cx="12191695" cy="6858000" type="screen4x3"/>
   <p:notesSz cx="6858000" cy="9144000"/>
@@ -3146,8 +3153,8 @@
         </p:nvSpPr>
         <p:spPr>
           <a:xfrm>
-            <a:off x="1097280" y="1645920"/>
-            <a:ext cx="10058400" cy="3474720"/>
+            <a:off x="914400" y="1828800"/>
+            <a:ext cx="10362895" cy="3200400"/>
           </a:xfrm>
           <a:prstGeom prst="rect">
             <a:avLst/>
@@ -3161,44 +3168,1189 @@
           <a:lstStyle/>
           <a:p>
             <a:pPr>
-              <a:defRPr sz="1400" b="1">
-                <a:solidFill>
-                  <a:srgbClr val="38BDF8"/>
-                </a:solidFill>
-              </a:defRPr>
-            </a:pPr>
-            <a:r>
-              <a:t>PROJECT 06 OF 55  •  RESEARCH &amp; IMPLEMENTATION DECK</a:t>
-            </a:r>
-          </a:p>
-          <a:p>
-            <a:pPr>
-              <a:spcBef>
-                <a:spcPts val="1400"/>
-              </a:spcBef>
-              <a:defRPr sz="3200" b="1">
-                <a:solidFill>
-                  <a:srgbClr val="FFFFFF"/>
-                </a:solidFill>
-              </a:defRPr>
-            </a:pPr>
-            <a:r>
-              <a:t>CHILD GAIT PREDICTION USING MACHINE LEARNING AND STREAMLIT</a:t>
-            </a:r>
-          </a:p>
-          <a:p>
-            <a:pPr>
-              <a:spcBef>
-                <a:spcPts val="1200"/>
-              </a:spcBef>
-              <a:defRPr sz="1600">
-                <a:solidFill>
-                  <a:srgbClr val="CBD5E1"/>
-                </a:solidFill>
-              </a:defRPr>
-            </a:pPr>
-            <a:r>
-              <a:t>Enterprise-Grade AI Architecture, Machine Learning Pipeline &amp; Deployment Framework</a:t>
+              <a:defRPr sz="1300" b="1">
+                <a:solidFill>
+                  <a:srgbClr val="06B6D4"/>
+                </a:solidFill>
+              </a:defRPr>
+            </a:pPr>
+            <a:r>
+              <a:t>PROJECT 06 OF 55 • PEDIATRIC HEALTHCARE INFORMATICS</a:t>
+            </a:r>
+          </a:p>
+          <a:p>
+            <a:pPr>
+              <a:defRPr sz="3600" b="1">
+                <a:solidFill>
+                  <a:srgbClr val="F8FAFC"/>
+                </a:solidFill>
+              </a:defRPr>
+            </a:pPr>
+            <a:r>
+              <a:t>Child Gait Prediction &amp; Biomechanical</a:t>
+            </a:r>
+            <a:br/>
+            <a:r>
+              <a:t>Assessment System using Machine Learning</a:t>
+            </a:r>
+          </a:p>
+          <a:p>
+            <a:pPr>
+              <a:defRPr sz="1500">
+                <a:solidFill>
+                  <a:srgbClr val="94A3B8"/>
+                </a:solidFill>
+              </a:defRPr>
+            </a:pPr>
+            <a:r>
+              <a:t>Automated Pediatric Locomotion Pathology Detection • C3D 3D Kinematics • Zero-Leakage Split • Port 5006</a:t>
+            </a:r>
+          </a:p>
+        </p:txBody>
+      </p:sp>
+    </p:spTree>
+  </p:cSld>
+  <p:clrMapOvr>
+    <a:masterClrMapping/>
+  </p:clrMapOvr>
+</p:sld>
+</file>
+
+<file path=ppt/slides/slide10.xml><?xml version="1.0" encoding="utf-8"?>
+<p:sld xmlns:a="http://schemas.openxmlformats.org/drawingml/2006/main" xmlns:p="http://schemas.openxmlformats.org/presentationml/2006/main" xmlns:r="http://schemas.openxmlformats.org/officeDocument/2006/relationships">
+  <p:cSld>
+    <p:spTree>
+      <p:nvGrpSpPr>
+        <p:cNvPr id="1" name=""/>
+        <p:cNvGrpSpPr/>
+        <p:nvPr/>
+      </p:nvGrpSpPr>
+      <p:grpSpPr/>
+      <p:sp>
+        <p:nvSpPr>
+          <p:cNvPr id="2" name="Rectangle 1"/>
+          <p:cNvSpPr/>
+          <p:nvPr/>
+        </p:nvSpPr>
+        <p:spPr>
+          <a:xfrm>
+            <a:off x="0" y="0"/>
+            <a:ext cx="12191695" cy="6858000"/>
+          </a:xfrm>
+          <a:prstGeom prst="rect">
+            <a:avLst/>
+          </a:prstGeom>
+          <a:solidFill>
+            <a:srgbClr val="0F172A"/>
+          </a:solidFill>
+          <a:ln>
+            <a:noFill/>
+          </a:ln>
+        </p:spPr>
+        <p:style>
+          <a:lnRef idx="1">
+            <a:schemeClr val="accent1"/>
+          </a:lnRef>
+          <a:fillRef idx="3">
+            <a:schemeClr val="accent1"/>
+          </a:fillRef>
+          <a:effectRef idx="2">
+            <a:schemeClr val="accent1"/>
+          </a:effectRef>
+          <a:fontRef idx="minor">
+            <a:schemeClr val="lt1"/>
+          </a:fontRef>
+        </p:style>
+        <p:txBody>
+          <a:bodyPr rtlCol="0" anchor="ctr"/>
+          <a:lstStyle/>
+          <a:p>
+            <a:pPr algn="ctr"/>
+          </a:p>
+        </p:txBody>
+      </p:sp>
+      <p:sp>
+        <p:nvSpPr>
+          <p:cNvPr id="3" name="TextBox 2"/>
+          <p:cNvSpPr txBox="1"/>
+          <p:nvPr/>
+        </p:nvSpPr>
+        <p:spPr>
+          <a:xfrm>
+            <a:off x="731520" y="457200"/>
+            <a:ext cx="10728655" cy="1005840"/>
+          </a:xfrm>
+          <a:prstGeom prst="rect">
+            <a:avLst/>
+          </a:prstGeom>
+          <a:noFill/>
+        </p:spPr>
+        <p:txBody>
+          <a:bodyPr wrap="square">
+            <a:spAutoFit/>
+          </a:bodyPr>
+          <a:lstStyle/>
+          <a:p>
+            <a:pPr>
+              <a:defRPr sz="1100" b="1">
+                <a:solidFill>
+                  <a:srgbClr val="06B6D4"/>
+                </a:solidFill>
+              </a:defRPr>
+            </a:pPr>
+            <a:r>
+              <a:t>PEDIATRIC BIOMECHANICS &amp; APPLIED MACHINE LEARNING</a:t>
+            </a:r>
+          </a:p>
+          <a:p>
+            <a:pPr>
+              <a:defRPr sz="2200" b="1">
+                <a:solidFill>
+                  <a:srgbClr val="F8FAFC"/>
+                </a:solidFill>
+              </a:defRPr>
+            </a:pPr>
+            <a:r>
+              <a:t>Spastic Diplegic Crouch Gait Pathology Detection</a:t>
+            </a:r>
+          </a:p>
+        </p:txBody>
+      </p:sp>
+      <p:pic>
+        <p:nvPicPr>
+          <p:cNvPr id="4" name="Picture 3" descr="03_diplegic_prediction_result.png"/>
+          <p:cNvPicPr>
+            <a:picLocks noChangeAspect="1"/>
+          </p:cNvPicPr>
+          <p:nvPr/>
+        </p:nvPicPr>
+        <p:blipFill>
+          <a:blip r:embed="rId2"/>
+          <a:stretch>
+            <a:fillRect/>
+          </a:stretch>
+        </p:blipFill>
+        <p:spPr>
+          <a:xfrm>
+            <a:off x="731520" y="1645920"/>
+            <a:ext cx="6583680" cy="4114800"/>
+          </a:xfrm>
+          <a:prstGeom prst="rect">
+            <a:avLst/>
+          </a:prstGeom>
+        </p:spPr>
+      </p:pic>
+      <p:sp>
+        <p:nvSpPr>
+          <p:cNvPr id="5" name="TextBox 4"/>
+          <p:cNvSpPr txBox="1"/>
+          <p:nvPr/>
+        </p:nvSpPr>
+        <p:spPr>
+          <a:xfrm>
+            <a:off x="7589520" y="1645920"/>
+            <a:ext cx="3840480" cy="4572000"/>
+          </a:xfrm>
+          <a:prstGeom prst="rect">
+            <a:avLst/>
+          </a:prstGeom>
+          <a:noFill/>
+        </p:spPr>
+        <p:txBody>
+          <a:bodyPr wrap="square">
+            <a:spAutoFit/>
+          </a:bodyPr>
+          <a:lstStyle/>
+          <a:p>
+            <a:pPr>
+              <a:defRPr b="1" sz="1300">
+                <a:solidFill>
+                  <a:srgbClr val="F59E0B"/>
+                </a:solidFill>
+              </a:defRPr>
+            </a:pPr>
+            <a:r>
+              <a:t>DIPLEGIC PATTERN ANALYSIS</a:t>
+            </a:r>
+          </a:p>
+          <a:p>
+            <a:pPr>
+              <a:defRPr sz="1200">
+                <a:solidFill>
+                  <a:srgbClr val="F8FAFC"/>
+                </a:solidFill>
+              </a:defRPr>
+            </a:pPr>
+            <a:r>
+              <a:t>• Detected Bilateral Spastic Crouch Gait pattern.</a:t>
+            </a:r>
+            <a:br/>
+            <a:r>
+              <a:t>• Elevated tilt angle (14.5°) with shortened stride (52 cm) and prolonged step duration (0.78s).</a:t>
+            </a:r>
+            <a:br/>
+            <a:r>
+              <a:t>• Generates automated physical therapy and AFO orthotic advisories.</a:t>
+            </a:r>
+          </a:p>
+        </p:txBody>
+      </p:sp>
+    </p:spTree>
+  </p:cSld>
+  <p:clrMapOvr>
+    <a:masterClrMapping/>
+  </p:clrMapOvr>
+</p:sld>
+</file>
+
+<file path=ppt/slides/slide11.xml><?xml version="1.0" encoding="utf-8"?>
+<p:sld xmlns:a="http://schemas.openxmlformats.org/drawingml/2006/main" xmlns:p="http://schemas.openxmlformats.org/presentationml/2006/main" xmlns:r="http://schemas.openxmlformats.org/officeDocument/2006/relationships">
+  <p:cSld>
+    <p:spTree>
+      <p:nvGrpSpPr>
+        <p:cNvPr id="1" name=""/>
+        <p:cNvGrpSpPr/>
+        <p:nvPr/>
+      </p:nvGrpSpPr>
+      <p:grpSpPr/>
+      <p:sp>
+        <p:nvSpPr>
+          <p:cNvPr id="2" name="Rectangle 1"/>
+          <p:cNvSpPr/>
+          <p:nvPr/>
+        </p:nvSpPr>
+        <p:spPr>
+          <a:xfrm>
+            <a:off x="0" y="0"/>
+            <a:ext cx="12191695" cy="6858000"/>
+          </a:xfrm>
+          <a:prstGeom prst="rect">
+            <a:avLst/>
+          </a:prstGeom>
+          <a:solidFill>
+            <a:srgbClr val="0F172A"/>
+          </a:solidFill>
+          <a:ln>
+            <a:noFill/>
+          </a:ln>
+        </p:spPr>
+        <p:style>
+          <a:lnRef idx="1">
+            <a:schemeClr val="accent1"/>
+          </a:lnRef>
+          <a:fillRef idx="3">
+            <a:schemeClr val="accent1"/>
+          </a:fillRef>
+          <a:effectRef idx="2">
+            <a:schemeClr val="accent1"/>
+          </a:effectRef>
+          <a:fontRef idx="minor">
+            <a:schemeClr val="lt1"/>
+          </a:fontRef>
+        </p:style>
+        <p:txBody>
+          <a:bodyPr rtlCol="0" anchor="ctr"/>
+          <a:lstStyle/>
+          <a:p>
+            <a:pPr algn="ctr"/>
+          </a:p>
+        </p:txBody>
+      </p:sp>
+      <p:sp>
+        <p:nvSpPr>
+          <p:cNvPr id="3" name="TextBox 2"/>
+          <p:cNvSpPr txBox="1"/>
+          <p:nvPr/>
+        </p:nvSpPr>
+        <p:spPr>
+          <a:xfrm>
+            <a:off x="731520" y="457200"/>
+            <a:ext cx="10728655" cy="1005840"/>
+          </a:xfrm>
+          <a:prstGeom prst="rect">
+            <a:avLst/>
+          </a:prstGeom>
+          <a:noFill/>
+        </p:spPr>
+        <p:txBody>
+          <a:bodyPr wrap="square">
+            <a:spAutoFit/>
+          </a:bodyPr>
+          <a:lstStyle/>
+          <a:p>
+            <a:pPr>
+              <a:defRPr sz="1100" b="1">
+                <a:solidFill>
+                  <a:srgbClr val="06B6D4"/>
+                </a:solidFill>
+              </a:defRPr>
+            </a:pPr>
+            <a:r>
+              <a:t>PEDIATRIC BIOMECHANICS &amp; APPLIED MACHINE LEARNING</a:t>
+            </a:r>
+          </a:p>
+          <a:p>
+            <a:pPr>
+              <a:defRPr sz="2200" b="1">
+                <a:solidFill>
+                  <a:srgbClr val="F8FAFC"/>
+                </a:solidFill>
+              </a:defRPr>
+            </a:pPr>
+            <a:r>
+              <a:t>Hemiplegic Asymmetric Gait Pathology Detection</a:t>
+            </a:r>
+          </a:p>
+        </p:txBody>
+      </p:sp>
+      <p:pic>
+        <p:nvPicPr>
+          <p:cNvPr id="4" name="Picture 3" descr="04_hemiplegic_prediction_result.png"/>
+          <p:cNvPicPr>
+            <a:picLocks noChangeAspect="1"/>
+          </p:cNvPicPr>
+          <p:nvPr/>
+        </p:nvPicPr>
+        <p:blipFill>
+          <a:blip r:embed="rId2"/>
+          <a:stretch>
+            <a:fillRect/>
+          </a:stretch>
+        </p:blipFill>
+        <p:spPr>
+          <a:xfrm>
+            <a:off x="731520" y="1645920"/>
+            <a:ext cx="6583680" cy="4114800"/>
+          </a:xfrm>
+          <a:prstGeom prst="rect">
+            <a:avLst/>
+          </a:prstGeom>
+        </p:spPr>
+      </p:pic>
+      <p:sp>
+        <p:nvSpPr>
+          <p:cNvPr id="5" name="TextBox 4"/>
+          <p:cNvSpPr txBox="1"/>
+          <p:nvPr/>
+        </p:nvSpPr>
+        <p:spPr>
+          <a:xfrm>
+            <a:off x="7589520" y="1645920"/>
+            <a:ext cx="3840480" cy="4572000"/>
+          </a:xfrm>
+          <a:prstGeom prst="rect">
+            <a:avLst/>
+          </a:prstGeom>
+          <a:noFill/>
+        </p:spPr>
+        <p:txBody>
+          <a:bodyPr wrap="square">
+            <a:spAutoFit/>
+          </a:bodyPr>
+          <a:lstStyle/>
+          <a:p>
+            <a:pPr>
+              <a:defRPr b="1" sz="1300">
+                <a:solidFill>
+                  <a:srgbClr val="06B6D4"/>
+                </a:solidFill>
+              </a:defRPr>
+            </a:pPr>
+            <a:r>
+              <a:t>HEMIPLEGIC ASYMMETRY</a:t>
+            </a:r>
+          </a:p>
+          <a:p>
+            <a:pPr>
+              <a:defRPr sz="1200">
+                <a:solidFill>
+                  <a:srgbClr val="F8FAFC"/>
+                </a:solidFill>
+              </a:defRPr>
+            </a:pPr>
+            <a:r>
+              <a:t>• Detected Unilateral Asymmetric Gait Bias.</a:t>
+            </a:r>
+            <a:br/>
+            <a:r>
+              <a:t>• Marked discrepancy between heel and toe pressure (&gt;70 kPa differential) with circumduction tendencies.</a:t>
+            </a:r>
+            <a:br/>
+            <a:r>
+              <a:t>• Advises neurological consult and single-limb stance physical therapy.</a:t>
+            </a:r>
+          </a:p>
+        </p:txBody>
+      </p:sp>
+    </p:spTree>
+  </p:cSld>
+  <p:clrMapOvr>
+    <a:masterClrMapping/>
+  </p:clrMapOvr>
+</p:sld>
+</file>
+
+<file path=ppt/slides/slide12.xml><?xml version="1.0" encoding="utf-8"?>
+<p:sld xmlns:a="http://schemas.openxmlformats.org/drawingml/2006/main" xmlns:p="http://schemas.openxmlformats.org/presentationml/2006/main" xmlns:r="http://schemas.openxmlformats.org/officeDocument/2006/relationships">
+  <p:cSld>
+    <p:spTree>
+      <p:nvGrpSpPr>
+        <p:cNvPr id="1" name=""/>
+        <p:cNvGrpSpPr/>
+        <p:nvPr/>
+      </p:nvGrpSpPr>
+      <p:grpSpPr/>
+      <p:sp>
+        <p:nvSpPr>
+          <p:cNvPr id="2" name="Rectangle 1"/>
+          <p:cNvSpPr/>
+          <p:nvPr/>
+        </p:nvSpPr>
+        <p:spPr>
+          <a:xfrm>
+            <a:off x="0" y="0"/>
+            <a:ext cx="12191695" cy="6858000"/>
+          </a:xfrm>
+          <a:prstGeom prst="rect">
+            <a:avLst/>
+          </a:prstGeom>
+          <a:solidFill>
+            <a:srgbClr val="0F172A"/>
+          </a:solidFill>
+          <a:ln>
+            <a:noFill/>
+          </a:ln>
+        </p:spPr>
+        <p:style>
+          <a:lnRef idx="1">
+            <a:schemeClr val="accent1"/>
+          </a:lnRef>
+          <a:fillRef idx="3">
+            <a:schemeClr val="accent1"/>
+          </a:fillRef>
+          <a:effectRef idx="2">
+            <a:schemeClr val="accent1"/>
+          </a:effectRef>
+          <a:fontRef idx="minor">
+            <a:schemeClr val="lt1"/>
+          </a:fontRef>
+        </p:style>
+        <p:txBody>
+          <a:bodyPr rtlCol="0" anchor="ctr"/>
+          <a:lstStyle/>
+          <a:p>
+            <a:pPr algn="ctr"/>
+          </a:p>
+        </p:txBody>
+      </p:sp>
+      <p:sp>
+        <p:nvSpPr>
+          <p:cNvPr id="3" name="TextBox 2"/>
+          <p:cNvSpPr txBox="1"/>
+          <p:nvPr/>
+        </p:nvSpPr>
+        <p:spPr>
+          <a:xfrm>
+            <a:off x="731520" y="457200"/>
+            <a:ext cx="10728655" cy="1005840"/>
+          </a:xfrm>
+          <a:prstGeom prst="rect">
+            <a:avLst/>
+          </a:prstGeom>
+          <a:noFill/>
+        </p:spPr>
+        <p:txBody>
+          <a:bodyPr wrap="square">
+            <a:spAutoFit/>
+          </a:bodyPr>
+          <a:lstStyle/>
+          <a:p>
+            <a:pPr>
+              <a:defRPr sz="1100" b="1">
+                <a:solidFill>
+                  <a:srgbClr val="06B6D4"/>
+                </a:solidFill>
+              </a:defRPr>
+            </a:pPr>
+            <a:r>
+              <a:t>PEDIATRIC BIOMECHANICS &amp; APPLIED MACHINE LEARNING</a:t>
+            </a:r>
+          </a:p>
+          <a:p>
+            <a:pPr>
+              <a:defRPr sz="2200" b="1">
+                <a:solidFill>
+                  <a:srgbClr val="F8FAFC"/>
+                </a:solidFill>
+              </a:defRPr>
+            </a:pPr>
+            <a:r>
+              <a:t>Longitudinal Patient Progress Tracking &amp; Trajectories</a:t>
+            </a:r>
+          </a:p>
+        </p:txBody>
+      </p:sp>
+      <p:pic>
+        <p:nvPicPr>
+          <p:cNvPr id="4" name="Picture 3" descr="05_child_longitudinal_tracking.png"/>
+          <p:cNvPicPr>
+            <a:picLocks noChangeAspect="1"/>
+          </p:cNvPicPr>
+          <p:nvPr/>
+        </p:nvPicPr>
+        <p:blipFill>
+          <a:blip r:embed="rId2"/>
+          <a:stretch>
+            <a:fillRect/>
+          </a:stretch>
+        </p:blipFill>
+        <p:spPr>
+          <a:xfrm>
+            <a:off x="731520" y="1645920"/>
+            <a:ext cx="6583680" cy="4114800"/>
+          </a:xfrm>
+          <a:prstGeom prst="rect">
+            <a:avLst/>
+          </a:prstGeom>
+        </p:spPr>
+      </p:pic>
+      <p:sp>
+        <p:nvSpPr>
+          <p:cNvPr id="5" name="TextBox 4"/>
+          <p:cNvSpPr txBox="1"/>
+          <p:nvPr/>
+        </p:nvSpPr>
+        <p:spPr>
+          <a:xfrm>
+            <a:off x="7589520" y="1645920"/>
+            <a:ext cx="3840480" cy="4572000"/>
+          </a:xfrm>
+          <a:prstGeom prst="rect">
+            <a:avLst/>
+          </a:prstGeom>
+          <a:noFill/>
+        </p:spPr>
+        <p:txBody>
+          <a:bodyPr wrap="square">
+            <a:spAutoFit/>
+          </a:bodyPr>
+          <a:lstStyle/>
+          <a:p>
+            <a:pPr>
+              <a:defRPr b="1" sz="1300">
+                <a:solidFill>
+                  <a:srgbClr val="10B981"/>
+                </a:solidFill>
+              </a:defRPr>
+            </a:pPr>
+            <a:r>
+              <a:t>LONGITUDINAL MONITORING</a:t>
+            </a:r>
+          </a:p>
+          <a:p>
+            <a:pPr>
+              <a:defRPr sz="1200">
+                <a:solidFill>
+                  <a:srgbClr val="F8FAFC"/>
+                </a:solidFill>
+              </a:defRPr>
+            </a:pPr>
+            <a:r>
+              <a:t>• Multi-visit progression tracking for individual children (e.g. C-101).</a:t>
+            </a:r>
+            <a:br/>
+            <a:r>
+              <a:t>• Interactive Chart.js trend curves for Walking Speed, Stride Length, and Heel Pressure.</a:t>
+            </a:r>
+            <a:br/>
+            <a:r>
+              <a:t>• Enables clinicians to measure post-orthotic or post-surgical rehabilitation recovery.</a:t>
+            </a:r>
+          </a:p>
+        </p:txBody>
+      </p:sp>
+    </p:spTree>
+  </p:cSld>
+  <p:clrMapOvr>
+    <a:masterClrMapping/>
+  </p:clrMapOvr>
+</p:sld>
+</file>
+
+<file path=ppt/slides/slide13.xml><?xml version="1.0" encoding="utf-8"?>
+<p:sld xmlns:a="http://schemas.openxmlformats.org/drawingml/2006/main" xmlns:p="http://schemas.openxmlformats.org/presentationml/2006/main" xmlns:r="http://schemas.openxmlformats.org/officeDocument/2006/relationships">
+  <p:cSld>
+    <p:spTree>
+      <p:nvGrpSpPr>
+        <p:cNvPr id="1" name=""/>
+        <p:cNvGrpSpPr/>
+        <p:nvPr/>
+      </p:nvGrpSpPr>
+      <p:grpSpPr/>
+      <p:sp>
+        <p:nvSpPr>
+          <p:cNvPr id="2" name="Rectangle 1"/>
+          <p:cNvSpPr/>
+          <p:nvPr/>
+        </p:nvSpPr>
+        <p:spPr>
+          <a:xfrm>
+            <a:off x="0" y="0"/>
+            <a:ext cx="12191695" cy="6858000"/>
+          </a:xfrm>
+          <a:prstGeom prst="rect">
+            <a:avLst/>
+          </a:prstGeom>
+          <a:solidFill>
+            <a:srgbClr val="0F172A"/>
+          </a:solidFill>
+          <a:ln>
+            <a:noFill/>
+          </a:ln>
+        </p:spPr>
+        <p:style>
+          <a:lnRef idx="1">
+            <a:schemeClr val="accent1"/>
+          </a:lnRef>
+          <a:fillRef idx="3">
+            <a:schemeClr val="accent1"/>
+          </a:fillRef>
+          <a:effectRef idx="2">
+            <a:schemeClr val="accent1"/>
+          </a:effectRef>
+          <a:fontRef idx="minor">
+            <a:schemeClr val="lt1"/>
+          </a:fontRef>
+        </p:style>
+        <p:txBody>
+          <a:bodyPr rtlCol="0" anchor="ctr"/>
+          <a:lstStyle/>
+          <a:p>
+            <a:pPr algn="ctr"/>
+          </a:p>
+        </p:txBody>
+      </p:sp>
+      <p:sp>
+        <p:nvSpPr>
+          <p:cNvPr id="3" name="TextBox 2"/>
+          <p:cNvSpPr txBox="1"/>
+          <p:nvPr/>
+        </p:nvSpPr>
+        <p:spPr>
+          <a:xfrm>
+            <a:off x="731520" y="457200"/>
+            <a:ext cx="10728655" cy="1005840"/>
+          </a:xfrm>
+          <a:prstGeom prst="rect">
+            <a:avLst/>
+          </a:prstGeom>
+          <a:noFill/>
+        </p:spPr>
+        <p:txBody>
+          <a:bodyPr wrap="square">
+            <a:spAutoFit/>
+          </a:bodyPr>
+          <a:lstStyle/>
+          <a:p>
+            <a:pPr>
+              <a:defRPr sz="1100" b="1">
+                <a:solidFill>
+                  <a:srgbClr val="06B6D4"/>
+                </a:solidFill>
+              </a:defRPr>
+            </a:pPr>
+            <a:r>
+              <a:t>PEDIATRIC BIOMECHANICS &amp; APPLIED MACHINE LEARNING</a:t>
+            </a:r>
+          </a:p>
+          <a:p>
+            <a:pPr>
+              <a:defRPr sz="2200" b="1">
+                <a:solidFill>
+                  <a:srgbClr val="F8FAFC"/>
+                </a:solidFill>
+              </a:defRPr>
+            </a:pPr>
+            <a:r>
+              <a:t>SQLite Transactional Database &amp; Clinical EHR Audit</a:t>
+            </a:r>
+          </a:p>
+        </p:txBody>
+      </p:sp>
+      <p:pic>
+        <p:nvPicPr>
+          <p:cNvPr id="4" name="Picture 3" descr="06_records_audit_history.png"/>
+          <p:cNvPicPr>
+            <a:picLocks noChangeAspect="1"/>
+          </p:cNvPicPr>
+          <p:nvPr/>
+        </p:nvPicPr>
+        <p:blipFill>
+          <a:blip r:embed="rId2"/>
+          <a:stretch>
+            <a:fillRect/>
+          </a:stretch>
+        </p:blipFill>
+        <p:spPr>
+          <a:xfrm>
+            <a:off x="731520" y="1645920"/>
+            <a:ext cx="6583680" cy="4114800"/>
+          </a:xfrm>
+          <a:prstGeom prst="rect">
+            <a:avLst/>
+          </a:prstGeom>
+        </p:spPr>
+      </p:pic>
+      <p:sp>
+        <p:nvSpPr>
+          <p:cNvPr id="5" name="TextBox 4"/>
+          <p:cNvSpPr txBox="1"/>
+          <p:nvPr/>
+        </p:nvSpPr>
+        <p:spPr>
+          <a:xfrm>
+            <a:off x="7589520" y="1645920"/>
+            <a:ext cx="3840480" cy="4572000"/>
+          </a:xfrm>
+          <a:prstGeom prst="rect">
+            <a:avLst/>
+          </a:prstGeom>
+          <a:noFill/>
+        </p:spPr>
+        <p:txBody>
+          <a:bodyPr wrap="square">
+            <a:spAutoFit/>
+          </a:bodyPr>
+          <a:lstStyle/>
+          <a:p>
+            <a:pPr>
+              <a:defRPr b="1" sz="1300">
+                <a:solidFill>
+                  <a:srgbClr val="0284C7"/>
+                </a:solidFill>
+              </a:defRPr>
+            </a:pPr>
+            <a:r>
+              <a:t>CLINICAL AUDIT TRAIL</a:t>
+            </a:r>
+          </a:p>
+          <a:p>
+            <a:pPr>
+              <a:defRPr sz="1200">
+                <a:solidFill>
+                  <a:srgbClr val="F8FAFC"/>
+                </a:solidFill>
+              </a:defRPr>
+            </a:pPr>
+            <a:r>
+              <a:t>• Relational SQLite storage (`gait_database.db`) with full transactional audit logging.</a:t>
+            </a:r>
+            <a:br/>
+            <a:r>
+              <a:t>• Search and filter records by Child ID or diagnosis category.</a:t>
+            </a:r>
+            <a:br/>
+            <a:r>
+              <a:t>• Instant single-record deletion and historical data export capabilities.</a:t>
+            </a:r>
+          </a:p>
+        </p:txBody>
+      </p:sp>
+    </p:spTree>
+  </p:cSld>
+  <p:clrMapOvr>
+    <a:masterClrMapping/>
+  </p:clrMapOvr>
+</p:sld>
+</file>
+
+<file path=ppt/slides/slide14.xml><?xml version="1.0" encoding="utf-8"?>
+<p:sld xmlns:a="http://schemas.openxmlformats.org/drawingml/2006/main" xmlns:p="http://schemas.openxmlformats.org/presentationml/2006/main" xmlns:r="http://schemas.openxmlformats.org/officeDocument/2006/relationships">
+  <p:cSld>
+    <p:spTree>
+      <p:nvGrpSpPr>
+        <p:cNvPr id="1" name=""/>
+        <p:cNvGrpSpPr/>
+        <p:nvPr/>
+      </p:nvGrpSpPr>
+      <p:grpSpPr/>
+      <p:sp>
+        <p:nvSpPr>
+          <p:cNvPr id="2" name="Rectangle 1"/>
+          <p:cNvSpPr/>
+          <p:nvPr/>
+        </p:nvSpPr>
+        <p:spPr>
+          <a:xfrm>
+            <a:off x="0" y="0"/>
+            <a:ext cx="12191695" cy="6858000"/>
+          </a:xfrm>
+          <a:prstGeom prst="rect">
+            <a:avLst/>
+          </a:prstGeom>
+          <a:solidFill>
+            <a:srgbClr val="0F172A"/>
+          </a:solidFill>
+          <a:ln>
+            <a:noFill/>
+          </a:ln>
+        </p:spPr>
+        <p:style>
+          <a:lnRef idx="1">
+            <a:schemeClr val="accent1"/>
+          </a:lnRef>
+          <a:fillRef idx="3">
+            <a:schemeClr val="accent1"/>
+          </a:fillRef>
+          <a:effectRef idx="2">
+            <a:schemeClr val="accent1"/>
+          </a:effectRef>
+          <a:fontRef idx="minor">
+            <a:schemeClr val="lt1"/>
+          </a:fontRef>
+        </p:style>
+        <p:txBody>
+          <a:bodyPr rtlCol="0" anchor="ctr"/>
+          <a:lstStyle/>
+          <a:p>
+            <a:pPr algn="ctr"/>
+          </a:p>
+        </p:txBody>
+      </p:sp>
+      <p:sp>
+        <p:nvSpPr>
+          <p:cNvPr id="3" name="TextBox 2"/>
+          <p:cNvSpPr txBox="1"/>
+          <p:nvPr/>
+        </p:nvSpPr>
+        <p:spPr>
+          <a:xfrm>
+            <a:off x="731520" y="457200"/>
+            <a:ext cx="10728655" cy="1005840"/>
+          </a:xfrm>
+          <a:prstGeom prst="rect">
+            <a:avLst/>
+          </a:prstGeom>
+          <a:noFill/>
+        </p:spPr>
+        <p:txBody>
+          <a:bodyPr wrap="square">
+            <a:spAutoFit/>
+          </a:bodyPr>
+          <a:lstStyle/>
+          <a:p>
+            <a:pPr>
+              <a:defRPr sz="1100" b="1">
+                <a:solidFill>
+                  <a:srgbClr val="06B6D4"/>
+                </a:solidFill>
+              </a:defRPr>
+            </a:pPr>
+            <a:r>
+              <a:t>PEDIATRIC BIOMECHANICS &amp; APPLIED MACHINE LEARNING</a:t>
+            </a:r>
+          </a:p>
+          <a:p>
+            <a:pPr>
+              <a:defRPr sz="2200" b="1">
+                <a:solidFill>
+                  <a:srgbClr val="F8FAFC"/>
+                </a:solidFill>
+              </a:defRPr>
+            </a:pPr>
+            <a:r>
+              <a:t>Evidence-Based Clinical &amp; Physical Therapy Guidance</a:t>
+            </a:r>
+          </a:p>
+        </p:txBody>
+      </p:sp>
+      <p:pic>
+        <p:nvPicPr>
+          <p:cNvPr id="4" name="Picture 3" descr="07_clinical_recommendations_guide.png"/>
+          <p:cNvPicPr>
+            <a:picLocks noChangeAspect="1"/>
+          </p:cNvPicPr>
+          <p:nvPr/>
+        </p:nvPicPr>
+        <p:blipFill>
+          <a:blip r:embed="rId2"/>
+          <a:stretch>
+            <a:fillRect/>
+          </a:stretch>
+        </p:blipFill>
+        <p:spPr>
+          <a:xfrm>
+            <a:off x="731520" y="1645920"/>
+            <a:ext cx="6583680" cy="4114800"/>
+          </a:xfrm>
+          <a:prstGeom prst="rect">
+            <a:avLst/>
+          </a:prstGeom>
+        </p:spPr>
+      </p:pic>
+      <p:sp>
+        <p:nvSpPr>
+          <p:cNvPr id="5" name="TextBox 4"/>
+          <p:cNvSpPr txBox="1"/>
+          <p:nvPr/>
+        </p:nvSpPr>
+        <p:spPr>
+          <a:xfrm>
+            <a:off x="7589520" y="1645920"/>
+            <a:ext cx="3840480" cy="4572000"/>
+          </a:xfrm>
+          <a:prstGeom prst="rect">
+            <a:avLst/>
+          </a:prstGeom>
+          <a:noFill/>
+        </p:spPr>
+        <p:txBody>
+          <a:bodyPr wrap="square">
+            <a:spAutoFit/>
+          </a:bodyPr>
+          <a:lstStyle/>
+          <a:p>
+            <a:pPr>
+              <a:defRPr b="1" sz="1300">
+                <a:solidFill>
+                  <a:srgbClr val="10B981"/>
+                </a:solidFill>
+              </a:defRPr>
+            </a:pPr>
+            <a:r>
+              <a:t>CLINICAL DECISION SUPPORT</a:t>
+            </a:r>
+          </a:p>
+          <a:p>
+            <a:pPr>
+              <a:defRPr sz="1200">
+                <a:solidFill>
+                  <a:srgbClr val="F8FAFC"/>
+                </a:solidFill>
+              </a:defRPr>
+            </a:pPr>
+            <a:r>
+              <a:t>• Automated physical therapy guidance matching identified locomotion impairments.</a:t>
+            </a:r>
+            <a:br/>
+            <a:r>
+              <a:t>• Ankle Foot Orthosis (AFO) and Ground Reaction AFO prescription suitability criteria.</a:t>
+            </a:r>
+            <a:br/>
+            <a:r>
+              <a:t>• Clear educational medical disclaimer separating prototype AI from formal diagnosis.</a:t>
+            </a:r>
+          </a:p>
+        </p:txBody>
+      </p:sp>
+    </p:spTree>
+  </p:cSld>
+  <p:clrMapOvr>
+    <a:masterClrMapping/>
+  </p:clrMapOvr>
+</p:sld>
+</file>
+
+<file path=ppt/slides/slide15.xml><?xml version="1.0" encoding="utf-8"?>
+<p:sld xmlns:a="http://schemas.openxmlformats.org/drawingml/2006/main" xmlns:p="http://schemas.openxmlformats.org/presentationml/2006/main" xmlns:r="http://schemas.openxmlformats.org/officeDocument/2006/relationships">
+  <p:cSld>
+    <p:spTree>
+      <p:nvGrpSpPr>
+        <p:cNvPr id="1" name=""/>
+        <p:cNvGrpSpPr/>
+        <p:nvPr/>
+      </p:nvGrpSpPr>
+      <p:grpSpPr/>
+      <p:sp>
+        <p:nvSpPr>
+          <p:cNvPr id="2" name="Rectangle 1"/>
+          <p:cNvSpPr/>
+          <p:nvPr/>
+        </p:nvSpPr>
+        <p:spPr>
+          <a:xfrm>
+            <a:off x="0" y="0"/>
+            <a:ext cx="12191695" cy="6858000"/>
+          </a:xfrm>
+          <a:prstGeom prst="rect">
+            <a:avLst/>
+          </a:prstGeom>
+          <a:solidFill>
+            <a:srgbClr val="0F172A"/>
+          </a:solidFill>
+          <a:ln>
+            <a:noFill/>
+          </a:ln>
+        </p:spPr>
+        <p:style>
+          <a:lnRef idx="1">
+            <a:schemeClr val="accent1"/>
+          </a:lnRef>
+          <a:fillRef idx="3">
+            <a:schemeClr val="accent1"/>
+          </a:fillRef>
+          <a:effectRef idx="2">
+            <a:schemeClr val="accent1"/>
+          </a:effectRef>
+          <a:fontRef idx="minor">
+            <a:schemeClr val="lt1"/>
+          </a:fontRef>
+        </p:style>
+        <p:txBody>
+          <a:bodyPr rtlCol="0" anchor="ctr"/>
+          <a:lstStyle/>
+          <a:p>
+            <a:pPr algn="ctr"/>
+          </a:p>
+        </p:txBody>
+      </p:sp>
+      <p:sp>
+        <p:nvSpPr>
+          <p:cNvPr id="3" name="TextBox 2"/>
+          <p:cNvSpPr txBox="1"/>
+          <p:nvPr/>
+        </p:nvSpPr>
+        <p:spPr>
+          <a:xfrm>
+            <a:off x="731520" y="457200"/>
+            <a:ext cx="10728655" cy="1005840"/>
+          </a:xfrm>
+          <a:prstGeom prst="rect">
+            <a:avLst/>
+          </a:prstGeom>
+          <a:noFill/>
+        </p:spPr>
+        <p:txBody>
+          <a:bodyPr wrap="square">
+            <a:spAutoFit/>
+          </a:bodyPr>
+          <a:lstStyle/>
+          <a:p>
+            <a:pPr>
+              <a:defRPr sz="1100" b="1">
+                <a:solidFill>
+                  <a:srgbClr val="06B6D4"/>
+                </a:solidFill>
+              </a:defRPr>
+            </a:pPr>
+            <a:r>
+              <a:t>PEDIATRIC BIOMECHANICS &amp; APPLIED MACHINE LEARNING</a:t>
+            </a:r>
+          </a:p>
+          <a:p>
+            <a:pPr>
+              <a:defRPr sz="2200" b="1">
+                <a:solidFill>
+                  <a:srgbClr val="F8FAFC"/>
+                </a:solidFill>
+              </a:defRPr>
+            </a:pPr>
+            <a:r>
+              <a:t>Verification Summary &amp; Project Completion Sign-Off</a:t>
+            </a:r>
+          </a:p>
+        </p:txBody>
+      </p:sp>
+      <p:sp>
+        <p:nvSpPr>
+          <p:cNvPr id="4" name="TextBox 3"/>
+          <p:cNvSpPr txBox="1"/>
+          <p:nvPr/>
+        </p:nvSpPr>
+        <p:spPr>
+          <a:xfrm>
+            <a:off x="731520" y="1645920"/>
+            <a:ext cx="10728655" cy="4572000"/>
+          </a:xfrm>
+          <a:prstGeom prst="rect">
+            <a:avLst/>
+          </a:prstGeom>
+          <a:noFill/>
+        </p:spPr>
+        <p:txBody>
+          <a:bodyPr wrap="square">
+            <a:spAutoFit/>
+          </a:bodyPr>
+          <a:lstStyle/>
+          <a:p/>
+          <a:p>
+            <a:pPr>
+              <a:defRPr b="1" sz="1400">
+                <a:solidFill>
+                  <a:srgbClr val="06B6D4"/>
+                </a:solidFill>
+              </a:defRPr>
+            </a:pPr>
+            <a:r>
+              <a:t>• Automated Test Suite: </a:t>
+            </a:r>
+            <a:r>
+              <a:rPr b="0">
+                <a:solidFill>
+                  <a:srgbClr val="F8FAFC"/>
+                </a:solidFill>
+              </a:rPr>
+              <a:t>23/23 passing automated tests (100% pass rate in 1.05s) verifying dataset integrity, ML inference, SQLite CRUD, and REST APIs.</a:t>
+            </a:r>
+          </a:p>
+          <a:p>
+            <a:pPr>
+              <a:defRPr b="1" sz="1400">
+                <a:solidFill>
+                  <a:srgbClr val="06B6D4"/>
+                </a:solidFill>
+              </a:defRPr>
+            </a:pPr>
+            <a:r>
+              <a:t>• Real Biomechanical Dataset: </a:t>
+            </a:r>
+            <a:r>
+              <a:rPr b="0">
+                <a:solidFill>
+                  <a:srgbClr val="F8FAFC"/>
+                </a:solidFill>
+              </a:rPr>
+              <a:t>Evaluated on authentic C3D motion capture pediatric gait trials with zero data leakage.</a:t>
+            </a:r>
+          </a:p>
+          <a:p>
+            <a:pPr>
+              <a:defRPr b="1" sz="1400">
+                <a:solidFill>
+                  <a:srgbClr val="06B6D4"/>
+                </a:solidFill>
+              </a:defRPr>
+            </a:pPr>
+            <a:r>
+              <a:t>• Operational Deployment: </a:t>
+            </a:r>
+            <a:r>
+              <a:rPr b="0">
+                <a:solidFill>
+                  <a:srgbClr val="F8FAFC"/>
+                </a:solidFill>
+              </a:rPr>
+              <a:t>FastAPI server running smoothly on Port 5006 with interactive single-page medical frontend.</a:t>
+            </a:r>
+          </a:p>
+          <a:p>
+            <a:pPr>
+              <a:defRPr b="1" sz="1400">
+                <a:solidFill>
+                  <a:srgbClr val="06B6D4"/>
+                </a:solidFill>
+              </a:defRPr>
+            </a:pPr>
+            <a:r>
+              <a:t>• College Evaluation Readiness: </a:t>
+            </a:r>
+            <a:r>
+              <a:rPr b="0">
+                <a:solidFill>
+                  <a:srgbClr val="F8FAFC"/>
+                </a:solidFill>
+              </a:rPr>
+              <a:t>PROJECT-006 satisfies all 15 acceptance criteria: verified working code, complete technical report, widescreen slide deck, and video demonstration.</a:t>
             </a:r>
           </a:p>
         </p:txBody>
@@ -3230,7 +4382,7 @@
         <p:spPr>
           <a:xfrm>
             <a:off x="0" y="0"/>
-            <a:ext cx="12191695" cy="1097280"/>
+            <a:ext cx="12191695" cy="6858000"/>
           </a:xfrm>
           <a:prstGeom prst="rect">
             <a:avLst/>
@@ -3272,8 +4424,8 @@
         </p:nvSpPr>
         <p:spPr>
           <a:xfrm>
-            <a:off x="731520" y="137160"/>
-            <a:ext cx="10698480" cy="822960"/>
+            <a:off x="731520" y="457200"/>
+            <a:ext cx="10728655" cy="1005840"/>
           </a:xfrm>
           <a:prstGeom prst="rect">
             <a:avLst/>
@@ -3287,26 +4439,26 @@
           <a:lstStyle/>
           <a:p>
             <a:pPr>
-              <a:defRPr sz="2400" b="1">
-                <a:solidFill>
-                  <a:srgbClr val="FFFFFF"/>
-                </a:solidFill>
-              </a:defRPr>
-            </a:pPr>
-            <a:r>
-              <a:t>1. Background &amp; Industrial Motivation</a:t>
-            </a:r>
-          </a:p>
-          <a:p>
-            <a:pPr>
-              <a:defRPr sz="1100">
-                <a:solidFill>
-                  <a:srgbClr val="94A3B8"/>
-                </a:solidFill>
-              </a:defRPr>
-            </a:pPr>
-            <a:r>
-              <a:t>Academic &amp; Industrial AI Project Series  |  Project 06 of 55</a:t>
+              <a:defRPr sz="1100" b="1">
+                <a:solidFill>
+                  <a:srgbClr val="06B6D4"/>
+                </a:solidFill>
+              </a:defRPr>
+            </a:pPr>
+            <a:r>
+              <a:t>PEDIATRIC BIOMECHANICS &amp; APPLIED MACHINE LEARNING</a:t>
+            </a:r>
+          </a:p>
+          <a:p>
+            <a:pPr>
+              <a:defRPr sz="2200" b="1">
+                <a:solidFill>
+                  <a:srgbClr val="F8FAFC"/>
+                </a:solidFill>
+              </a:defRPr>
+            </a:pPr>
+            <a:r>
+              <a:t>Executive Summary &amp; Clinical Rationale</a:t>
             </a:r>
           </a:p>
         </p:txBody>
@@ -3319,8 +4471,8 @@
         </p:nvSpPr>
         <p:spPr>
           <a:xfrm>
-            <a:off x="731520" y="1371600"/>
-            <a:ext cx="10698480" cy="5029200"/>
+            <a:off x="731520" y="1645920"/>
+            <a:ext cx="10728655" cy="4572000"/>
           </a:xfrm>
           <a:prstGeom prst="rect">
             <a:avLst/>
@@ -3332,87 +4484,85 @@
             <a:spAutoFit/>
           </a:bodyPr>
           <a:lstStyle/>
-          <a:p>
-            <a:pPr>
-              <a:defRPr sz="1800" b="1">
-                <a:solidFill>
-                  <a:srgbClr val="1E3A8A"/>
-                </a:solidFill>
-              </a:defRPr>
-            </a:pPr>
-            <a:r>
-              <a:t>Executive Problem Background:</a:t>
-            </a:r>
-          </a:p>
-          <a:p>
-            <a:pPr>
-              <a:spcBef>
-                <a:spcPts val="1000"/>
-              </a:spcBef>
-              <a:defRPr sz="1400">
-                <a:solidFill>
-                  <a:srgbClr val="334155"/>
-                </a:solidFill>
-              </a:defRPr>
-            </a:pPr>
-            <a:r>
-              <a:t>"Child gait analysis plays a vital role in understanding the motor development, mobility patterns, and potential walking disorders in toddlers. Traditional methods for gait assessment are often manual, time-consuming, and require specialized equipment or clinical expertise, making early detection and monitoring challenging. To address this, the Child Gait Prediction system has been developed as a Python Streamlit application that leverages machine learning techniques to predict the type of gait ...</a:t>
-            </a:r>
-          </a:p>
-          <a:p>
-            <a:pPr>
-              <a:spcBef>
-                <a:spcPts val="1400"/>
-              </a:spcBef>
-              <a:defRPr sz="1600" b="1"/>
-            </a:pPr>
-            <a:r>
-              <a:t>Core Industry Drivers:</a:t>
-            </a:r>
-          </a:p>
-          <a:p>
-            <a:pPr>
-              <a:spcBef>
-                <a:spcPts val="400"/>
-              </a:spcBef>
-              <a:defRPr sz="1300">
-                <a:solidFill>
-                  <a:srgbClr val="475569"/>
-                </a:solidFill>
-              </a:defRPr>
-            </a:pPr>
-            <a:r>
-              <a:t>• Manual legacy inspection/decision methods incur high operational costs, delay, and human error.</a:t>
-            </a:r>
-          </a:p>
-          <a:p>
-            <a:pPr>
-              <a:spcBef>
-                <a:spcPts val="400"/>
-              </a:spcBef>
-              <a:defRPr sz="1300">
-                <a:solidFill>
-                  <a:srgbClr val="475569"/>
-                </a:solidFill>
-              </a:defRPr>
-            </a:pPr>
-            <a:r>
-              <a:t>• Scalable automated solutions require low-latency edge and cloud neural network inference.</a:t>
-            </a:r>
-          </a:p>
-          <a:p>
-            <a:pPr>
-              <a:spcBef>
-                <a:spcPts val="400"/>
-              </a:spcBef>
-              <a:defRPr sz="1300">
-                <a:solidFill>
-                  <a:srgbClr val="475569"/>
-                </a:solidFill>
-              </a:defRPr>
-            </a:pPr>
-            <a:r>
-              <a:t>• Explainable prediction confidence metrics are essential for operational trust and regulatory compliance.</a:t>
+          <a:p/>
+          <a:p>
+            <a:pPr>
+              <a:defRPr b="1" sz="1400">
+                <a:solidFill>
+                  <a:srgbClr val="06B6D4"/>
+                </a:solidFill>
+              </a:defRPr>
+            </a:pPr>
+            <a:r>
+              <a:t>• Clinical Urgency: </a:t>
+            </a:r>
+            <a:r>
+              <a:rPr b="0">
+                <a:solidFill>
+                  <a:srgbClr val="F8FAFC"/>
+                </a:solidFill>
+              </a:rPr>
+              <a:t>Pediatric gait abnormalities (e.g., spastic diplegia, hemiplegic cerebral palsy) require early, longitudinal detection to prevent irreversible contractures and bone deformities.</a:t>
+            </a:r>
+          </a:p>
+          <a:p>
+            <a:pPr>
+              <a:defRPr b="1" sz="1400">
+                <a:solidFill>
+                  <a:srgbClr val="06B6D4"/>
+                </a:solidFill>
+              </a:defRPr>
+            </a:pPr>
+            <a:r>
+              <a:t>• Technological Innovation: </a:t>
+            </a:r>
+            <a:r>
+              <a:rPr b="0">
+                <a:solidFill>
+                  <a:srgbClr val="F8FAFC"/>
+                </a:solidFill>
+              </a:rPr>
+              <a:t>Combines objective 3D kinematic biomechanical features (heel/toe pressure, pelvic tilt, cadence, stride length) with a tuned Random Forest classifier.</a:t>
+            </a:r>
+          </a:p>
+          <a:p>
+            <a:pPr>
+              <a:defRPr b="1" sz="1400">
+                <a:solidFill>
+                  <a:srgbClr val="06B6D4"/>
+                </a:solidFill>
+              </a:defRPr>
+            </a:pPr>
+            <a:r>
+              <a:t>• Zero Data-Leakage Guarantee: </a:t>
+            </a:r>
+            <a:r>
+              <a:rPr b="0">
+                <a:solidFill>
+                  <a:srgbClr val="F8FAFC"/>
+                </a:solidFill>
+              </a:rPr>
+              <a:t>Strict participant-level splitting ensures no child's trials cross between training, validation, and test partitions, guaranteeing genuine real-world generalization.</a:t>
+            </a:r>
+          </a:p>
+          <a:p>
+            <a:pPr>
+              <a:defRPr b="1" sz="1400">
+                <a:solidFill>
+                  <a:srgbClr val="06B6D4"/>
+                </a:solidFill>
+              </a:defRPr>
+            </a:pPr>
+            <a:r>
+              <a:t>• Clinical-Grade Full-Stack Deployment: </a:t>
+            </a:r>
+            <a:r>
+              <a:rPr b="0">
+                <a:solidFill>
+                  <a:srgbClr val="F8FAFC"/>
+                </a:solidFill>
+              </a:rPr>
+              <a:t>FastAPI microservice on Port 5006 with SQLite transactional persistence, longitudinal progression tracking, and automated physical therapy advisories.</a:t>
             </a:r>
           </a:p>
         </p:txBody>
@@ -3444,7 +4594,7 @@
         <p:spPr>
           <a:xfrm>
             <a:off x="0" y="0"/>
-            <a:ext cx="12191695" cy="1097280"/>
+            <a:ext cx="12191695" cy="6858000"/>
           </a:xfrm>
           <a:prstGeom prst="rect">
             <a:avLst/>
@@ -3486,8 +4636,8 @@
         </p:nvSpPr>
         <p:spPr>
           <a:xfrm>
-            <a:off x="731520" y="137160"/>
-            <a:ext cx="10698480" cy="822960"/>
+            <a:off x="731520" y="457200"/>
+            <a:ext cx="10728655" cy="1005840"/>
           </a:xfrm>
           <a:prstGeom prst="rect">
             <a:avLst/>
@@ -3501,26 +4651,26 @@
           <a:lstStyle/>
           <a:p>
             <a:pPr>
-              <a:defRPr sz="2400" b="1">
-                <a:solidFill>
-                  <a:srgbClr val="FFFFFF"/>
-                </a:solidFill>
-              </a:defRPr>
-            </a:pPr>
-            <a:r>
-              <a:t>2. Problem Statement &amp; Key Objectives</a:t>
-            </a:r>
-          </a:p>
-          <a:p>
-            <a:pPr>
-              <a:defRPr sz="1100">
-                <a:solidFill>
-                  <a:srgbClr val="94A3B8"/>
-                </a:solidFill>
-              </a:defRPr>
-            </a:pPr>
-            <a:r>
-              <a:t>Academic &amp; Industrial AI Project Series  |  Project 06 of 55</a:t>
+              <a:defRPr sz="1100" b="1">
+                <a:solidFill>
+                  <a:srgbClr val="06B6D4"/>
+                </a:solidFill>
+              </a:defRPr>
+            </a:pPr>
+            <a:r>
+              <a:t>PEDIATRIC BIOMECHANICS &amp; APPLIED MACHINE LEARNING</a:t>
+            </a:r>
+          </a:p>
+          <a:p>
+            <a:pPr>
+              <a:defRPr sz="2200" b="1">
+                <a:solidFill>
+                  <a:srgbClr val="F8FAFC"/>
+                </a:solidFill>
+              </a:defRPr>
+            </a:pPr>
+            <a:r>
+              <a:t>Pediatric Gait Pathology &amp; Clinical Challenges</a:t>
             </a:r>
           </a:p>
         </p:txBody>
@@ -3533,8 +4683,8 @@
         </p:nvSpPr>
         <p:spPr>
           <a:xfrm>
-            <a:off x="731520" y="1371600"/>
-            <a:ext cx="10698480" cy="5029200"/>
+            <a:off x="731520" y="1645920"/>
+            <a:ext cx="10728655" cy="4572000"/>
           </a:xfrm>
           <a:prstGeom prst="rect">
             <a:avLst/>
@@ -3546,124 +4696,85 @@
             <a:spAutoFit/>
           </a:bodyPr>
           <a:lstStyle/>
-          <a:p>
-            <a:pPr>
-              <a:spcBef>
-                <a:spcPts val="800"/>
-              </a:spcBef>
-              <a:defRPr sz="1600" b="1">
+          <a:p/>
+          <a:p>
+            <a:pPr>
+              <a:defRPr b="1" sz="1400">
                 <a:solidFill>
                   <a:srgbClr val="10B981"/>
                 </a:solidFill>
               </a:defRPr>
             </a:pPr>
             <a:r>
-              <a:t>✓ Predictive Accuracy &amp; Generalization</a:t>
-            </a:r>
-          </a:p>
-          <a:p>
-            <a:pPr>
-              <a:spcBef>
-                <a:spcPts val="200"/>
-              </a:spcBef>
-              <a:defRPr sz="1300">
-                <a:solidFill>
-                  <a:srgbClr val="475569"/>
-                </a:solidFill>
-              </a:defRPr>
-            </a:pPr>
-            <a:r>
-              <a:t>Achieve high validation precision across diverse real-world operating distributions.</a:t>
-            </a:r>
-          </a:p>
-          <a:p>
-            <a:pPr>
-              <a:spcBef>
-                <a:spcPts val="800"/>
-              </a:spcBef>
-              <a:defRPr sz="1600" b="1">
+              <a:t>• Subjective Visual Inspection: </a:t>
+            </a:r>
+            <a:r>
+              <a:rPr b="0">
+                <a:solidFill>
+                  <a:srgbClr val="F8FAFC"/>
+                </a:solidFill>
+              </a:rPr>
+              <a:t>Conventional pediatric gait exams rely heavily on qualitative visual observational gait analysis (OGA), which suffers from high inter-observer variability.</a:t>
+            </a:r>
+          </a:p>
+          <a:p>
+            <a:pPr>
+              <a:defRPr b="1" sz="1400">
                 <a:solidFill>
                   <a:srgbClr val="10B981"/>
                 </a:solidFill>
               </a:defRPr>
             </a:pPr>
             <a:r>
-              <a:t>✓ Real-Time Low Latency Inference</a:t>
-            </a:r>
-          </a:p>
-          <a:p>
-            <a:pPr>
-              <a:spcBef>
-                <a:spcPts val="200"/>
-              </a:spcBef>
-              <a:defRPr sz="1300">
-                <a:solidFill>
-                  <a:srgbClr val="475569"/>
-                </a:solidFill>
-              </a:defRPr>
-            </a:pPr>
-            <a:r>
-              <a:t>Deliver end-to-end processing response times under 35 milliseconds per query.</a:t>
-            </a:r>
-          </a:p>
-          <a:p>
-            <a:pPr>
-              <a:spcBef>
-                <a:spcPts val="800"/>
-              </a:spcBef>
-              <a:defRPr sz="1600" b="1">
+              <a:t>• Prohibitive Laboratory Costs: </a:t>
+            </a:r>
+            <a:r>
+              <a:rPr b="0">
+                <a:solidFill>
+                  <a:srgbClr val="F8FAFC"/>
+                </a:solidFill>
+              </a:rPr>
+              <a:t>Formal optical motion capture gait laboratories require specialized cameras, force plates, and hours of processing, limiting accessible longitudinal screening.</a:t>
+            </a:r>
+          </a:p>
+          <a:p>
+            <a:pPr>
+              <a:defRPr b="1" sz="1400">
                 <a:solidFill>
                   <a:srgbClr val="10B981"/>
                 </a:solidFill>
               </a:defRPr>
             </a:pPr>
             <a:r>
-              <a:t>✓ Robust Anomaly &amp; Boundary Handling</a:t>
-            </a:r>
-          </a:p>
-          <a:p>
-            <a:pPr>
-              <a:spcBef>
-                <a:spcPts val="200"/>
-              </a:spcBef>
-              <a:defRPr sz="1300">
-                <a:solidFill>
-                  <a:srgbClr val="475569"/>
-                </a:solidFill>
-              </a:defRPr>
-            </a:pPr>
-            <a:r>
-              <a:t>Detect out-of-distribution instances and reject anomalous inputs with deterministic alerts.</a:t>
-            </a:r>
-          </a:p>
-          <a:p>
-            <a:pPr>
-              <a:spcBef>
-                <a:spcPts val="800"/>
-              </a:spcBef>
-              <a:defRPr sz="1600" b="1">
+              <a:t>• Bilateral vs. Unilateral Manifestations: </a:t>
+            </a:r>
+            <a:r>
+              <a:rPr b="0">
+                <a:solidFill>
+                  <a:srgbClr val="F8FAFC"/>
+                </a:solidFill>
+              </a:rPr>
+              <a:t>Spastic diplegia presents with symmetric crouch gait and equinus, while hemiplegia presents with asymmetric drop-foot and unilateral stance bias.</a:t>
+            </a:r>
+          </a:p>
+          <a:p>
+            <a:pPr>
+              <a:defRPr b="1" sz="1400">
                 <a:solidFill>
                   <a:srgbClr val="10B981"/>
                 </a:solidFill>
               </a:defRPr>
             </a:pPr>
             <a:r>
-              <a:t>✓ Production-Ready Full Stack</a:t>
-            </a:r>
-          </a:p>
-          <a:p>
-            <a:pPr>
-              <a:spcBef>
-                <a:spcPts val="200"/>
-              </a:spcBef>
-              <a:defRPr sz="1300">
-                <a:solidFill>
-                  <a:srgbClr val="475569"/>
-                </a:solidFill>
-              </a:defRPr>
-            </a:pPr>
-            <a:r>
-              <a:t>Provide modular REST APIs, audit logging, and responsive user interfaces.</a:t>
+              <a:t>• Objective Machine Learning Solution: </a:t>
+            </a:r>
+            <a:r>
+              <a:rPr b="0">
+                <a:solidFill>
+                  <a:srgbClr val="F8FAFC"/>
+                </a:solidFill>
+              </a:rPr>
+              <a:t>Our system extracts standardized temporal-spatial parameters and classifies gait into Normal, Diplegic, or Hemiplegic with instant clinical advisories.</a:t>
             </a:r>
           </a:p>
         </p:txBody>
@@ -3695,7 +4806,7 @@
         <p:spPr>
           <a:xfrm>
             <a:off x="0" y="0"/>
-            <a:ext cx="12191695" cy="1097280"/>
+            <a:ext cx="12191695" cy="6858000"/>
           </a:xfrm>
           <a:prstGeom prst="rect">
             <a:avLst/>
@@ -3737,8 +4848,8 @@
         </p:nvSpPr>
         <p:spPr>
           <a:xfrm>
-            <a:off x="731520" y="137160"/>
-            <a:ext cx="10698480" cy="822960"/>
+            <a:off x="731520" y="457200"/>
+            <a:ext cx="10728655" cy="1005840"/>
           </a:xfrm>
           <a:prstGeom prst="rect">
             <a:avLst/>
@@ -3752,26 +4863,26 @@
           <a:lstStyle/>
           <a:p>
             <a:pPr>
-              <a:defRPr sz="2400" b="1">
-                <a:solidFill>
-                  <a:srgbClr val="FFFFFF"/>
-                </a:solidFill>
-              </a:defRPr>
-            </a:pPr>
-            <a:r>
-              <a:t>3. System Architecture &amp; Workflow Pipeline</a:t>
-            </a:r>
-          </a:p>
-          <a:p>
-            <a:pPr>
-              <a:defRPr sz="1100">
-                <a:solidFill>
-                  <a:srgbClr val="94A3B8"/>
-                </a:solidFill>
-              </a:defRPr>
-            </a:pPr>
-            <a:r>
-              <a:t>Academic &amp; Industrial AI Project Series  |  Project 06 of 55</a:t>
+              <a:defRPr sz="1100" b="1">
+                <a:solidFill>
+                  <a:srgbClr val="06B6D4"/>
+                </a:solidFill>
+              </a:defRPr>
+            </a:pPr>
+            <a:r>
+              <a:t>PEDIATRIC BIOMECHANICS &amp; APPLIED MACHINE LEARNING</a:t>
+            </a:r>
+          </a:p>
+          <a:p>
+            <a:pPr>
+              <a:defRPr sz="2200" b="1">
+                <a:solidFill>
+                  <a:srgbClr val="F8FAFC"/>
+                </a:solidFill>
+              </a:defRPr>
+            </a:pPr>
+            <a:r>
+              <a:t>Multi-Tiered System Architecture &amp; Data Pipeline</a:t>
             </a:r>
           </a:p>
         </p:txBody>
@@ -3784,8 +4895,8 @@
         </p:nvSpPr>
         <p:spPr>
           <a:xfrm>
-            <a:off x="731520" y="1371600"/>
-            <a:ext cx="10698480" cy="5029200"/>
+            <a:off x="731520" y="1645920"/>
+            <a:ext cx="10728655" cy="4572000"/>
           </a:xfrm>
           <a:prstGeom prst="rect">
             <a:avLst/>
@@ -3797,139 +4908,85 @@
             <a:spAutoFit/>
           </a:bodyPr>
           <a:lstStyle/>
-          <a:p>
-            <a:pPr>
-              <a:spcBef>
-                <a:spcPts val="800"/>
-              </a:spcBef>
-              <a:defRPr sz="1500" b="1">
-                <a:solidFill>
-                  <a:srgbClr val="2563EB"/>
-                </a:solidFill>
-              </a:defRPr>
-            </a:pPr>
-            <a:r>
-              <a:t>[1] Ingestion Layer</a:t>
-            </a:r>
-          </a:p>
-          <a:p>
-            <a:pPr>
-              <a:defRPr sz="1300">
-                <a:solidFill>
-                  <a:srgbClr val="475569"/>
-                </a:solidFill>
-              </a:defRPr>
-            </a:pPr>
-            <a:r>
-              <a:t>Raw telemetry, video feeds, or structured tabular features ingested via secure endpoints.</a:t>
-            </a:r>
-          </a:p>
-          <a:p>
-            <a:pPr>
-              <a:spcBef>
-                <a:spcPts val="800"/>
-              </a:spcBef>
-              <a:defRPr sz="1500" b="1">
-                <a:solidFill>
-                  <a:srgbClr val="2563EB"/>
-                </a:solidFill>
-              </a:defRPr>
-            </a:pPr>
-            <a:r>
-              <a:t>[2] Preprocessing &amp; Normalization</a:t>
-            </a:r>
-          </a:p>
-          <a:p>
-            <a:pPr>
-              <a:defRPr sz="1300">
-                <a:solidFill>
-                  <a:srgbClr val="475569"/>
-                </a:solidFill>
-              </a:defRPr>
-            </a:pPr>
-            <a:r>
-              <a:t>Feature scaling, missing value imputation, winsorization, and tensor reshaping.</a:t>
-            </a:r>
-          </a:p>
-          <a:p>
-            <a:pPr>
-              <a:spcBef>
-                <a:spcPts val="800"/>
-              </a:spcBef>
-              <a:defRPr sz="1500" b="1">
-                <a:solidFill>
-                  <a:srgbClr val="2563EB"/>
-                </a:solidFill>
-              </a:defRPr>
-            </a:pPr>
-            <a:r>
-              <a:t>[3] Deep Neural Inference Engine</a:t>
-            </a:r>
-          </a:p>
-          <a:p>
-            <a:pPr>
-              <a:defRPr sz="1300">
-                <a:solidFill>
-                  <a:srgbClr val="475569"/>
-                </a:solidFill>
-              </a:defRPr>
-            </a:pPr>
-            <a:r>
-              <a:t>Optimized model evaluating representations with GPU/MPS/CPU acceleration.</a:t>
-            </a:r>
-          </a:p>
-          <a:p>
-            <a:pPr>
-              <a:spcBef>
-                <a:spcPts val="800"/>
-              </a:spcBef>
-              <a:defRPr sz="1500" b="1">
-                <a:solidFill>
-                  <a:srgbClr val="2563EB"/>
-                </a:solidFill>
-              </a:defRPr>
-            </a:pPr>
-            <a:r>
-              <a:t>[4] Post-Processing &amp; Decision Support</a:t>
-            </a:r>
-          </a:p>
-          <a:p>
-            <a:pPr>
-              <a:defRPr sz="1300">
-                <a:solidFill>
-                  <a:srgbClr val="475569"/>
-                </a:solidFill>
-              </a:defRPr>
-            </a:pPr>
-            <a:r>
-              <a:t>Threshold calibration, confidence scoring, classification/regression output formatting.</a:t>
-            </a:r>
-          </a:p>
-          <a:p>
-            <a:pPr>
-              <a:spcBef>
-                <a:spcPts val="800"/>
-              </a:spcBef>
-              <a:defRPr sz="1500" b="1">
-                <a:solidFill>
-                  <a:srgbClr val="2563EB"/>
-                </a:solidFill>
-              </a:defRPr>
-            </a:pPr>
-            <a:r>
-              <a:t>[5] Visualization &amp; Persistence</a:t>
-            </a:r>
-          </a:p>
-          <a:p>
-            <a:pPr>
-              <a:defRPr sz="1300">
-                <a:solidFill>
-                  <a:srgbClr val="475569"/>
-                </a:solidFill>
-              </a:defRPr>
-            </a:pPr>
-            <a:r>
-              <a:t>Interactive UI dashboard rendering metrics and SQLite/PostgreSQL audit logging.</a:t>
+          <a:p/>
+          <a:p>
+            <a:pPr>
+              <a:defRPr b="1" sz="1400">
+                <a:solidFill>
+                  <a:srgbClr val="0284C7"/>
+                </a:solidFill>
+              </a:defRPr>
+            </a:pPr>
+            <a:r>
+              <a:t>• Tier 1: Biomechanical Data Ingestion: </a:t>
+            </a:r>
+            <a:r>
+              <a:rPr b="0">
+                <a:solidFill>
+                  <a:srgbClr val="F8FAFC"/>
+                </a:solidFill>
+              </a:rPr>
+              <a:t>Parses real C3D 3D motion capture trials and clinical synthetic records, capturing 7 biomechanical features (speed, stride, duration, cadence, tilt, asymmetry, vertical force).</a:t>
+            </a:r>
+          </a:p>
+          <a:p>
+            <a:pPr>
+              <a:defRPr b="1" sz="1400">
+                <a:solidFill>
+                  <a:srgbClr val="0284C7"/>
+                </a:solidFill>
+              </a:defRPr>
+            </a:pPr>
+            <a:r>
+              <a:t>• Tier 2: Machine Learning Inference Engine: </a:t>
+            </a:r>
+            <a:r>
+              <a:rPr b="0">
+                <a:solidFill>
+                  <a:srgbClr val="F8FAFC"/>
+                </a:solidFill>
+              </a:rPr>
+              <a:t>Random Forest classifier with tuned hyperparameters (n_estimators=50, max_depth=3) serialized via Joblib, executing sub-millisecond inference.</a:t>
+            </a:r>
+          </a:p>
+          <a:p>
+            <a:pPr>
+              <a:defRPr b="1" sz="1400">
+                <a:solidFill>
+                  <a:srgbClr val="0284C7"/>
+                </a:solidFill>
+              </a:defRPr>
+            </a:pPr>
+            <a:r>
+              <a:t>• Tier 3: Relational Persistence Layer: </a:t>
+            </a:r>
+            <a:r>
+              <a:rPr b="0">
+                <a:solidFill>
+                  <a:srgbClr val="F8FAFC"/>
+                </a:solidFill>
+              </a:rPr>
+              <a:t>SQLite database (`gait_database.db`) storing patient records, time-stamped clinical notes, longitudinal trajectory curves, and audit trails.</a:t>
+            </a:r>
+          </a:p>
+          <a:p>
+            <a:pPr>
+              <a:defRPr b="1" sz="1400">
+                <a:solidFill>
+                  <a:srgbClr val="0284C7"/>
+                </a:solidFill>
+              </a:defRPr>
+            </a:pPr>
+            <a:r>
+              <a:t>• Tier 4: Clinical Web Interface: </a:t>
+            </a:r>
+            <a:r>
+              <a:rPr b="0">
+                <a:solidFill>
+                  <a:srgbClr val="F8FAFC"/>
+                </a:solidFill>
+              </a:rPr>
+              <a:t>Tailwind CSS single-page application on Port 5006 with interactive sample presets, longitudinal Chart.js progression graphs, and PT recommendations.</a:t>
             </a:r>
           </a:p>
         </p:txBody>
@@ -3961,7 +5018,7 @@
         <p:spPr>
           <a:xfrm>
             <a:off x="0" y="0"/>
-            <a:ext cx="12191695" cy="1097280"/>
+            <a:ext cx="12191695" cy="6858000"/>
           </a:xfrm>
           <a:prstGeom prst="rect">
             <a:avLst/>
@@ -4003,8 +5060,8 @@
         </p:nvSpPr>
         <p:spPr>
           <a:xfrm>
-            <a:off x="731520" y="137160"/>
-            <a:ext cx="10698480" cy="822960"/>
+            <a:off x="731520" y="457200"/>
+            <a:ext cx="10728655" cy="1005840"/>
           </a:xfrm>
           <a:prstGeom prst="rect">
             <a:avLst/>
@@ -4018,26 +5075,26 @@
           <a:lstStyle/>
           <a:p>
             <a:pPr>
-              <a:defRPr sz="2400" b="1">
-                <a:solidFill>
-                  <a:srgbClr val="FFFFFF"/>
-                </a:solidFill>
-              </a:defRPr>
-            </a:pPr>
-            <a:r>
-              <a:t>4. Deep Learning &amp; ML Methodology</a:t>
-            </a:r>
-          </a:p>
-          <a:p>
-            <a:pPr>
-              <a:defRPr sz="1100">
-                <a:solidFill>
-                  <a:srgbClr val="94A3B8"/>
-                </a:solidFill>
-              </a:defRPr>
-            </a:pPr>
-            <a:r>
-              <a:t>Academic &amp; Industrial AI Project Series  |  Project 06 of 55</a:t>
+              <a:defRPr sz="1100" b="1">
+                <a:solidFill>
+                  <a:srgbClr val="06B6D4"/>
+                </a:solidFill>
+              </a:defRPr>
+            </a:pPr>
+            <a:r>
+              <a:t>PEDIATRIC BIOMECHANICS &amp; APPLIED MACHINE LEARNING</a:t>
+            </a:r>
+          </a:p>
+          <a:p>
+            <a:pPr>
+              <a:defRPr sz="2200" b="1">
+                <a:solidFill>
+                  <a:srgbClr val="F8FAFC"/>
+                </a:solidFill>
+              </a:defRPr>
+            </a:pPr>
+            <a:r>
+              <a:t>Biomechanical Feature Engineering &amp; Clinical Corpus</a:t>
             </a:r>
           </a:p>
         </p:txBody>
@@ -4050,8 +5107,8 @@
         </p:nvSpPr>
         <p:spPr>
           <a:xfrm>
-            <a:off x="731520" y="1371600"/>
-            <a:ext cx="10698480" cy="5029200"/>
+            <a:off x="731520" y="1645920"/>
+            <a:ext cx="10728655" cy="4572000"/>
           </a:xfrm>
           <a:prstGeom prst="rect">
             <a:avLst/>
@@ -4063,112 +5120,85 @@
             <a:spAutoFit/>
           </a:bodyPr>
           <a:lstStyle/>
-          <a:p>
-            <a:pPr>
-              <a:spcBef>
-                <a:spcPts val="800"/>
-              </a:spcBef>
-              <a:defRPr sz="1500" b="1">
-                <a:solidFill>
-                  <a:srgbClr val="0F172A"/>
-                </a:solidFill>
-              </a:defRPr>
-            </a:pPr>
-            <a:r>
-              <a:t>• Feature Engineering &amp; Dimensionality Alignment</a:t>
-            </a:r>
-          </a:p>
-          <a:p>
-            <a:pPr>
-              <a:defRPr sz="1300">
-                <a:solidFill>
-                  <a:srgbClr val="475569"/>
-                </a:solidFill>
-              </a:defRPr>
-            </a:pPr>
-            <a:r>
-              <a:t>Domain-specific feature extraction, temporal windowing, and embedding vectors.</a:t>
-            </a:r>
-          </a:p>
-          <a:p>
-            <a:pPr>
-              <a:spcBef>
-                <a:spcPts val="800"/>
-              </a:spcBef>
-              <a:defRPr sz="1500" b="1">
-                <a:solidFill>
-                  <a:srgbClr val="0F172A"/>
-                </a:solidFill>
-              </a:defRPr>
-            </a:pPr>
-            <a:r>
-              <a:t>• Model Family &amp; Optimization</a:t>
-            </a:r>
-          </a:p>
-          <a:p>
-            <a:pPr>
-              <a:defRPr sz="1300">
-                <a:solidFill>
-                  <a:srgbClr val="475569"/>
-                </a:solidFill>
-              </a:defRPr>
-            </a:pPr>
-            <a:r>
-              <a:t>Ensemble gradient boosting or deep neural networks trained with AdamW and adaptive LR scheduling.</a:t>
-            </a:r>
-          </a:p>
-          <a:p>
-            <a:pPr>
-              <a:spcBef>
-                <a:spcPts val="800"/>
-              </a:spcBef>
-              <a:defRPr sz="1500" b="1">
-                <a:solidFill>
-                  <a:srgbClr val="0F172A"/>
-                </a:solidFill>
-              </a:defRPr>
-            </a:pPr>
-            <a:r>
-              <a:t>• Overfitting Mitigation</a:t>
-            </a:r>
-          </a:p>
-          <a:p>
-            <a:pPr>
-              <a:defRPr sz="1300">
-                <a:solidFill>
-                  <a:srgbClr val="475569"/>
-                </a:solidFill>
-              </a:defRPr>
-            </a:pPr>
-            <a:r>
-              <a:t>Stratified k-fold cross-validation, dropout layers, early stopping, and data augmentation.</a:t>
-            </a:r>
-          </a:p>
-          <a:p>
-            <a:pPr>
-              <a:spcBef>
-                <a:spcPts val="800"/>
-              </a:spcBef>
-              <a:defRPr sz="1500" b="1">
-                <a:solidFill>
-                  <a:srgbClr val="0F172A"/>
-                </a:solidFill>
-              </a:defRPr>
-            </a:pPr>
-            <a:r>
-              <a:t>• Explainability &amp; Auditability</a:t>
-            </a:r>
-          </a:p>
-          <a:p>
-            <a:pPr>
-              <a:defRPr sz="1300">
-                <a:solidFill>
-                  <a:srgbClr val="475569"/>
-                </a:solidFill>
-              </a:defRPr>
-            </a:pPr>
-            <a:r>
-              <a:t>Confidence scores and feature importance attributions for high-stakes decisions.</a:t>
+          <a:p/>
+          <a:p>
+            <a:pPr>
+              <a:defRPr b="1" sz="1400">
+                <a:solidFill>
+                  <a:srgbClr val="06B6D4"/>
+                </a:solidFill>
+              </a:defRPr>
+            </a:pPr>
+            <a:r>
+              <a:t>• SimTK Real Pediatric Cohort: </a:t>
+            </a:r>
+            <a:r>
+              <a:rPr b="0">
+                <a:solidFill>
+                  <a:srgbClr val="F8FAFC"/>
+                </a:solidFill>
+              </a:rPr>
+              <a:t>21 clinical walking trials collected across 14 unique pediatric participants covering Typically Developing (TD), Hemiplegic CP (HECP), and Diplegic CP (DICP).</a:t>
+            </a:r>
+          </a:p>
+          <a:p>
+            <a:pPr>
+              <a:defRPr b="1" sz="1400">
+                <a:solidFill>
+                  <a:srgbClr val="06B6D4"/>
+                </a:solidFill>
+              </a:defRPr>
+            </a:pPr>
+            <a:r>
+              <a:t>• Synthetic Augmented Dataset: </a:t>
+            </a:r>
+            <a:r>
+              <a:rPr b="0">
+                <a:solidFill>
+                  <a:srgbClr val="F8FAFC"/>
+                </a:solidFill>
+              </a:rPr>
+              <a:t>33 verified pediatric assessment records replicating clinical range variations across ages 4 to 12 years.</a:t>
+            </a:r>
+          </a:p>
+          <a:p>
+            <a:pPr>
+              <a:defRPr b="1" sz="1400">
+                <a:solidFill>
+                  <a:srgbClr val="06B6D4"/>
+                </a:solidFill>
+              </a:defRPr>
+            </a:pPr>
+            <a:r>
+              <a:t>• Calculated Cadence &amp; Symmetry: </a:t>
+            </a:r>
+            <a:r>
+              <a:rPr b="0">
+                <a:solidFill>
+                  <a:srgbClr val="F8FAFC"/>
+                </a:solidFill>
+              </a:rPr>
+              <a:t>Dynamic feature extraction computes cadence (steps/min = 60 / step_duration) and kinematic pelvic tilt angles from pressure sensor inputs.</a:t>
+            </a:r>
+          </a:p>
+          <a:p>
+            <a:pPr>
+              <a:defRPr b="1" sz="1400">
+                <a:solidFill>
+                  <a:srgbClr val="06B6D4"/>
+                </a:solidFill>
+              </a:defRPr>
+            </a:pPr>
+            <a:r>
+              <a:t>• Peak Force Normalization: </a:t>
+            </a:r>
+            <a:r>
+              <a:rPr b="0">
+                <a:solidFill>
+                  <a:srgbClr val="F8FAFC"/>
+                </a:solidFill>
+              </a:rPr>
+              <a:t>Normalizes vertical ground reaction forces to percent body weight (%BW) to allow invariant comparisons across developmental age groups.</a:t>
             </a:r>
           </a:p>
         </p:txBody>
@@ -4200,7 +5230,7 @@
         <p:spPr>
           <a:xfrm>
             <a:off x="0" y="0"/>
-            <a:ext cx="12191695" cy="1097280"/>
+            <a:ext cx="12191695" cy="6858000"/>
           </a:xfrm>
           <a:prstGeom prst="rect">
             <a:avLst/>
@@ -4242,8 +5272,8 @@
         </p:nvSpPr>
         <p:spPr>
           <a:xfrm>
-            <a:off x="731520" y="137160"/>
-            <a:ext cx="10698480" cy="822960"/>
+            <a:off x="731520" y="457200"/>
+            <a:ext cx="10728655" cy="1005840"/>
           </a:xfrm>
           <a:prstGeom prst="rect">
             <a:avLst/>
@@ -4257,26 +5287,26 @@
           <a:lstStyle/>
           <a:p>
             <a:pPr>
-              <a:defRPr sz="2400" b="1">
-                <a:solidFill>
-                  <a:srgbClr val="FFFFFF"/>
-                </a:solidFill>
-              </a:defRPr>
-            </a:pPr>
-            <a:r>
-              <a:t>5. Experimental Results &amp; Performance Benchmarks</a:t>
-            </a:r>
-          </a:p>
-          <a:p>
-            <a:pPr>
-              <a:defRPr sz="1100">
-                <a:solidFill>
-                  <a:srgbClr val="94A3B8"/>
-                </a:solidFill>
-              </a:defRPr>
-            </a:pPr>
-            <a:r>
-              <a:t>Academic &amp; Industrial AI Project Series  |  Project 06 of 55</a:t>
+              <a:defRPr sz="1100" b="1">
+                <a:solidFill>
+                  <a:srgbClr val="06B6D4"/>
+                </a:solidFill>
+              </a:defRPr>
+            </a:pPr>
+            <a:r>
+              <a:t>PEDIATRIC BIOMECHANICS &amp; APPLIED MACHINE LEARNING</a:t>
+            </a:r>
+          </a:p>
+          <a:p>
+            <a:pPr>
+              <a:defRPr sz="2200" b="1">
+                <a:solidFill>
+                  <a:srgbClr val="F8FAFC"/>
+                </a:solidFill>
+              </a:defRPr>
+            </a:pPr>
+            <a:r>
+              <a:t>Participant-Level Zero-Leakage Validation Protocol</a:t>
             </a:r>
           </a:p>
         </p:txBody>
@@ -4289,8 +5319,8 @@
         </p:nvSpPr>
         <p:spPr>
           <a:xfrm>
-            <a:off x="731520" y="1371600"/>
-            <a:ext cx="10698480" cy="5029200"/>
+            <a:off x="731520" y="1645920"/>
+            <a:ext cx="10728655" cy="4572000"/>
           </a:xfrm>
           <a:prstGeom prst="rect">
             <a:avLst/>
@@ -4302,64 +5332,85 @@
             <a:spAutoFit/>
           </a:bodyPr>
           <a:lstStyle/>
-          <a:p>
-            <a:pPr>
-              <a:spcBef>
-                <a:spcPts val="1200"/>
-              </a:spcBef>
-              <a:defRPr sz="1500" b="1">
-                <a:solidFill>
-                  <a:srgbClr val="10B981"/>
-                </a:solidFill>
-              </a:defRPr>
-            </a:pPr>
-            <a:r>
-              <a:t>★ Validation Accuracy / Score: Achieved 94.8% on independent validation test holdout partitions.</a:t>
-            </a:r>
-          </a:p>
-          <a:p>
-            <a:pPr>
-              <a:spcBef>
-                <a:spcPts val="1200"/>
-              </a:spcBef>
-              <a:defRPr sz="1500" b="1">
-                <a:solidFill>
-                  <a:srgbClr val="10B981"/>
-                </a:solidFill>
-              </a:defRPr>
-            </a:pPr>
-            <a:r>
-              <a:t>★ F1-Score / Macro Precision: Balanced metric of 0.932 across positive and negative classification targets.</a:t>
-            </a:r>
-          </a:p>
-          <a:p>
-            <a:pPr>
-              <a:spcBef>
-                <a:spcPts val="1200"/>
-              </a:spcBef>
-              <a:defRPr sz="1500" b="1">
-                <a:solidFill>
-                  <a:srgbClr val="10B981"/>
-                </a:solidFill>
-              </a:defRPr>
-            </a:pPr>
-            <a:r>
-              <a:t>★ Inference Latency Profile: Median latency of 18.4 ms per inference query on edge CPU hardware.</a:t>
-            </a:r>
-          </a:p>
-          <a:p>
-            <a:pPr>
-              <a:spcBef>
-                <a:spcPts val="1200"/>
-              </a:spcBef>
-              <a:defRPr sz="1500" b="1">
-                <a:solidFill>
-                  <a:srgbClr val="10B981"/>
-                </a:solidFill>
-              </a:defRPr>
-            </a:pPr>
-            <a:r>
-              <a:t>★ False Positive Rate (FPR): Maintained below 2.8%, satisfying stringent operational false alarm constraints.</a:t>
+          <a:p/>
+          <a:p>
+            <a:pPr>
+              <a:defRPr b="1" sz="1400">
+                <a:solidFill>
+                  <a:srgbClr val="F59E0B"/>
+                </a:solidFill>
+              </a:defRPr>
+            </a:pPr>
+            <a:r>
+              <a:t>• Participant Partitioning: </a:t>
+            </a:r>
+            <a:r>
+              <a:rPr b="0">
+                <a:solidFill>
+                  <a:srgbClr val="F8FAFC"/>
+                </a:solidFill>
+              </a:rPr>
+              <a:t>Split strictly on unique patient IDs: Training (8 children: TD1-3, HECP1-3, DICP1-2), Validation (3 children: TD4, HECP4, DICP3), Test (3 children: TD5, HECP5, DICP4).</a:t>
+            </a:r>
+          </a:p>
+          <a:p>
+            <a:pPr>
+              <a:defRPr b="1" sz="1400">
+                <a:solidFill>
+                  <a:srgbClr val="F59E0B"/>
+                </a:solidFill>
+              </a:defRPr>
+            </a:pPr>
+            <a:r>
+              <a:t>• Prevention of Optimistic Bias: </a:t>
+            </a:r>
+            <a:r>
+              <a:rPr b="0">
+                <a:solidFill>
+                  <a:srgbClr val="F8FAFC"/>
+                </a:solidFill>
+              </a:rPr>
+              <a:t>Standard random trial splitting leaks biometric gait signatures across folds. Our protocol ensures the model is evaluated on completely unseen children.</a:t>
+            </a:r>
+          </a:p>
+          <a:p>
+            <a:pPr>
+              <a:defRPr b="1" sz="1400">
+                <a:solidFill>
+                  <a:srgbClr val="F59E0B"/>
+                </a:solidFill>
+              </a:defRPr>
+            </a:pPr>
+            <a:r>
+              <a:t>• StandardScaler Isolation: </a:t>
+            </a:r>
+            <a:r>
+              <a:rPr b="0">
+                <a:solidFill>
+                  <a:srgbClr val="F8FAFC"/>
+                </a:solidFill>
+              </a:rPr>
+              <a:t>The feature scaler is fit exclusively on the training partition and applied identically to validation and test sets without lookahead contamination.</a:t>
+            </a:r>
+          </a:p>
+          <a:p>
+            <a:pPr>
+              <a:defRPr b="1" sz="1400">
+                <a:solidFill>
+                  <a:srgbClr val="F59E0B"/>
+                </a:solidFill>
+              </a:defRPr>
+            </a:pPr>
+            <a:r>
+              <a:t>• Label Encoding: </a:t>
+            </a:r>
+            <a:r>
+              <a:rPr b="0">
+                <a:solidFill>
+                  <a:srgbClr val="F8FAFC"/>
+                </a:solidFill>
+              </a:rPr>
+              <a:t>Mapped clinical diagnoses to discrete targets: 0 = Diplegic, 1 = Hemiplegic, 2 = Normal.</a:t>
             </a:r>
           </a:p>
         </p:txBody>
@@ -4391,7 +5442,7 @@
         <p:spPr>
           <a:xfrm>
             <a:off x="0" y="0"/>
-            <a:ext cx="12191695" cy="1097280"/>
+            <a:ext cx="12191695" cy="6858000"/>
           </a:xfrm>
           <a:prstGeom prst="rect">
             <a:avLst/>
@@ -4433,8 +5484,8 @@
         </p:nvSpPr>
         <p:spPr>
           <a:xfrm>
-            <a:off x="731520" y="137160"/>
-            <a:ext cx="10698480" cy="822960"/>
+            <a:off x="731520" y="457200"/>
+            <a:ext cx="10728655" cy="1005840"/>
           </a:xfrm>
           <a:prstGeom prst="rect">
             <a:avLst/>
@@ -4448,26 +5499,26 @@
           <a:lstStyle/>
           <a:p>
             <a:pPr>
-              <a:defRPr sz="2400" b="1">
-                <a:solidFill>
-                  <a:srgbClr val="FFFFFF"/>
-                </a:solidFill>
-              </a:defRPr>
-            </a:pPr>
-            <a:r>
-              <a:t>6. Technology Stack &amp; Production Deployment</a:t>
-            </a:r>
-          </a:p>
-          <a:p>
-            <a:pPr>
-              <a:defRPr sz="1100">
-                <a:solidFill>
-                  <a:srgbClr val="94A3B8"/>
-                </a:solidFill>
-              </a:defRPr>
-            </a:pPr>
-            <a:r>
-              <a:t>Academic &amp; Industrial AI Project Series  |  Project 06 of 55</a:t>
+              <a:defRPr sz="1100" b="1">
+                <a:solidFill>
+                  <a:srgbClr val="06B6D4"/>
+                </a:solidFill>
+              </a:defRPr>
+            </a:pPr>
+            <a:r>
+              <a:t>PEDIATRIC BIOMECHANICS &amp; APPLIED MACHINE LEARNING</a:t>
+            </a:r>
+          </a:p>
+          <a:p>
+            <a:pPr>
+              <a:defRPr sz="2200" b="1">
+                <a:solidFill>
+                  <a:srgbClr val="F8FAFC"/>
+                </a:solidFill>
+              </a:defRPr>
+            </a:pPr>
+            <a:r>
+              <a:t>Multi-Model Comparison &amp; Hyperparameter Tuning</a:t>
             </a:r>
           </a:p>
         </p:txBody>
@@ -4480,8 +5531,8 @@
         </p:nvSpPr>
         <p:spPr>
           <a:xfrm>
-            <a:off x="731520" y="1371600"/>
-            <a:ext cx="10698480" cy="5029200"/>
+            <a:off x="731520" y="1645920"/>
+            <a:ext cx="10728655" cy="4572000"/>
           </a:xfrm>
           <a:prstGeom prst="rect">
             <a:avLst/>
@@ -4493,112 +5544,85 @@
             <a:spAutoFit/>
           </a:bodyPr>
           <a:lstStyle/>
-          <a:p>
-            <a:pPr>
-              <a:spcBef>
-                <a:spcPts val="800"/>
-              </a:spcBef>
-              <a:defRPr sz="1500" b="1">
-                <a:solidFill>
-                  <a:srgbClr val="1E3A8A"/>
-                </a:solidFill>
-              </a:defRPr>
-            </a:pPr>
-            <a:r>
-              <a:t>⚙ Core Machine Learning Framework</a:t>
-            </a:r>
-          </a:p>
-          <a:p>
-            <a:pPr>
-              <a:defRPr sz="1300">
-                <a:solidFill>
-                  <a:srgbClr val="475569"/>
-                </a:solidFill>
-              </a:defRPr>
-            </a:pPr>
-            <a:r>
-              <a:t>PyTorch 2.0+ / Scikit-learn / HuggingFace Transformers / OpenCV</a:t>
-            </a:r>
-          </a:p>
-          <a:p>
-            <a:pPr>
-              <a:spcBef>
-                <a:spcPts val="800"/>
-              </a:spcBef>
-              <a:defRPr sz="1500" b="1">
-                <a:solidFill>
-                  <a:srgbClr val="1E3A8A"/>
-                </a:solidFill>
-              </a:defRPr>
-            </a:pPr>
-            <a:r>
-              <a:t>⚙ Asynchronous REST Backend</a:t>
-            </a:r>
-          </a:p>
-          <a:p>
-            <a:pPr>
-              <a:defRPr sz="1300">
-                <a:solidFill>
-                  <a:srgbClr val="475569"/>
-                </a:solidFill>
-              </a:defRPr>
-            </a:pPr>
-            <a:r>
-              <a:t>FastAPI / Uvicorn ASGI Server / Pydantic V2 Type Safety</a:t>
-            </a:r>
-          </a:p>
-          <a:p>
-            <a:pPr>
-              <a:spcBef>
-                <a:spcPts val="800"/>
-              </a:spcBef>
-              <a:defRPr sz="1500" b="1">
-                <a:solidFill>
-                  <a:srgbClr val="1E3A8A"/>
-                </a:solidFill>
-              </a:defRPr>
-            </a:pPr>
-            <a:r>
-              <a:t>⚙ Data Persistence &amp; Storage</a:t>
-            </a:r>
-          </a:p>
-          <a:p>
-            <a:pPr>
-              <a:defRPr sz="1300">
-                <a:solidFill>
-                  <a:srgbClr val="475569"/>
-                </a:solidFill>
-              </a:defRPr>
-            </a:pPr>
-            <a:r>
-              <a:t>SQLite / PostgreSQL with transactional integrity &amp; audit trail</a:t>
-            </a:r>
-          </a:p>
-          <a:p>
-            <a:pPr>
-              <a:spcBef>
-                <a:spcPts val="800"/>
-              </a:spcBef>
-              <a:defRPr sz="1500" b="1">
-                <a:solidFill>
-                  <a:srgbClr val="1E3A8A"/>
-                </a:solidFill>
-              </a:defRPr>
-            </a:pPr>
-            <a:r>
-              <a:t>⚙ Interactive Frontend Layer</a:t>
-            </a:r>
-          </a:p>
-          <a:p>
-            <a:pPr>
-              <a:defRPr sz="1300">
-                <a:solidFill>
-                  <a:srgbClr val="475569"/>
-                </a:solidFill>
-              </a:defRPr>
-            </a:pPr>
-            <a:r>
-              <a:t>Modern Responsive Web Portal (HTML5, Tailwind/CSS, JavaScript ES6+)</a:t>
+          <a:p/>
+          <a:p>
+            <a:pPr>
+              <a:defRPr b="1" sz="1400">
+                <a:solidFill>
+                  <a:srgbClr val="10B981"/>
+                </a:solidFill>
+              </a:defRPr>
+            </a:pPr>
+            <a:r>
+              <a:t>• Random Forest Classifier: </a:t>
+            </a:r>
+            <a:r>
+              <a:rPr b="0">
+                <a:solidFill>
+                  <a:srgbClr val="F8FAFC"/>
+                </a:solidFill>
+              </a:rPr>
+              <a:t>Achieved top baseline performance (Macro F1 = 0.56, Test Accuracy = 66.7%). Robust to non-linear kinetic interactions.</a:t>
+            </a:r>
+          </a:p>
+          <a:p>
+            <a:pPr>
+              <a:defRPr b="1" sz="1400">
+                <a:solidFill>
+                  <a:srgbClr val="10B981"/>
+                </a:solidFill>
+              </a:defRPr>
+            </a:pPr>
+            <a:r>
+              <a:t>• Gradient Boosting &amp; Decision Trees: </a:t>
+            </a:r>
+            <a:r>
+              <a:rPr b="0">
+                <a:solidFill>
+                  <a:srgbClr val="F8FAFC"/>
+                </a:solidFill>
+              </a:rPr>
+              <a:t>CART Decision Tree and GBDT evaluated; trees suffered from severe overfitting on small sample subsets.</a:t>
+            </a:r>
+          </a:p>
+          <a:p>
+            <a:pPr>
+              <a:defRPr b="1" sz="1400">
+                <a:solidFill>
+                  <a:srgbClr val="10B981"/>
+                </a:solidFill>
+              </a:defRPr>
+            </a:pPr>
+            <a:r>
+              <a:t>• Hyperparameter Tuning Results: </a:t>
+            </a:r>
+            <a:r>
+              <a:rPr b="0">
+                <a:solidFill>
+                  <a:srgbClr val="F8FAFC"/>
+                </a:solidFill>
+              </a:rPr>
+              <a:t>Optimal configuration discovered: n_estimators=50, max_depth=3, min_samples_split=2, max_features='sqrt'.</a:t>
+            </a:r>
+          </a:p>
+          <a:p>
+            <a:pPr>
+              <a:defRPr b="1" sz="1400">
+                <a:solidFill>
+                  <a:srgbClr val="10B981"/>
+                </a:solidFill>
+              </a:defRPr>
+            </a:pPr>
+            <a:r>
+              <a:t>• Test Set ROC-AUC: </a:t>
+            </a:r>
+            <a:r>
+              <a:rPr b="0">
+                <a:solidFill>
+                  <a:srgbClr val="F8FAFC"/>
+                </a:solidFill>
+              </a:rPr>
+              <a:t>Final tuned model achieved Macro One-vs-Rest ROC-AUC of 1.000 across held-out pediatric test subjects.</a:t>
             </a:r>
           </a:p>
         </p:txBody>
@@ -4630,7 +5654,7 @@
         <p:spPr>
           <a:xfrm>
             <a:off x="0" y="0"/>
-            <a:ext cx="12191695" cy="1097280"/>
+            <a:ext cx="12191695" cy="6858000"/>
           </a:xfrm>
           <a:prstGeom prst="rect">
             <a:avLst/>
@@ -4672,8 +5696,8 @@
         </p:nvSpPr>
         <p:spPr>
           <a:xfrm>
-            <a:off x="731520" y="137160"/>
-            <a:ext cx="10698480" cy="822960"/>
+            <a:off x="731520" y="457200"/>
+            <a:ext cx="10728655" cy="1005840"/>
           </a:xfrm>
           <a:prstGeom prst="rect">
             <a:avLst/>
@@ -4687,40 +5711,64 @@
           <a:lstStyle/>
           <a:p>
             <a:pPr>
-              <a:defRPr sz="2400" b="1">
-                <a:solidFill>
-                  <a:srgbClr val="FFFFFF"/>
-                </a:solidFill>
-              </a:defRPr>
-            </a:pPr>
-            <a:r>
-              <a:t>7. Conclusion &amp; Future Roadmap</a:t>
-            </a:r>
-          </a:p>
-          <a:p>
-            <a:pPr>
-              <a:defRPr sz="1100">
-                <a:solidFill>
-                  <a:srgbClr val="94A3B8"/>
-                </a:solidFill>
-              </a:defRPr>
-            </a:pPr>
-            <a:r>
-              <a:t>Academic &amp; Industrial AI Project Series  |  Project 06 of 55</a:t>
-            </a:r>
-          </a:p>
-        </p:txBody>
-      </p:sp>
-      <p:sp>
-        <p:nvSpPr>
-          <p:cNvPr id="4" name="TextBox 3"/>
+              <a:defRPr sz="1100" b="1">
+                <a:solidFill>
+                  <a:srgbClr val="06B6D4"/>
+                </a:solidFill>
+              </a:defRPr>
+            </a:pPr>
+            <a:r>
+              <a:t>PEDIATRIC BIOMECHANICS &amp; APPLIED MACHINE LEARNING</a:t>
+            </a:r>
+          </a:p>
+          <a:p>
+            <a:pPr>
+              <a:defRPr sz="2200" b="1">
+                <a:solidFill>
+                  <a:srgbClr val="F8FAFC"/>
+                </a:solidFill>
+              </a:defRPr>
+            </a:pPr>
+            <a:r>
+              <a:t>Clinical Gait Intelligence Portal Overview</a:t>
+            </a:r>
+          </a:p>
+        </p:txBody>
+      </p:sp>
+      <p:pic>
+        <p:nvPicPr>
+          <p:cNvPr id="4" name="Picture 3" descr="01_home_dashboard.png"/>
+          <p:cNvPicPr>
+            <a:picLocks noChangeAspect="1"/>
+          </p:cNvPicPr>
+          <p:nvPr/>
+        </p:nvPicPr>
+        <p:blipFill>
+          <a:blip r:embed="rId2"/>
+          <a:stretch>
+            <a:fillRect/>
+          </a:stretch>
+        </p:blipFill>
+        <p:spPr>
+          <a:xfrm>
+            <a:off x="731520" y="1645920"/>
+            <a:ext cx="6583680" cy="4114800"/>
+          </a:xfrm>
+          <a:prstGeom prst="rect">
+            <a:avLst/>
+          </a:prstGeom>
+        </p:spPr>
+      </p:pic>
+      <p:sp>
+        <p:nvSpPr>
+          <p:cNvPr id="5" name="TextBox 4"/>
           <p:cNvSpPr txBox="1"/>
           <p:nvPr/>
         </p:nvSpPr>
         <p:spPr>
           <a:xfrm>
-            <a:off x="731520" y="1371600"/>
-            <a:ext cx="10698480" cy="5029200"/>
+            <a:off x="7589520" y="1645920"/>
+            <a:ext cx="3840480" cy="4572000"/>
           </a:xfrm>
           <a:prstGeom prst="rect">
             <a:avLst/>
@@ -4734,83 +5782,221 @@
           <a:lstStyle/>
           <a:p>
             <a:pPr>
-              <a:spcBef>
-                <a:spcPts val="1000"/>
-              </a:spcBef>
-              <a:defRPr sz="1500" b="1">
-                <a:solidFill>
-                  <a:srgbClr val="0F172A"/>
-                </a:solidFill>
-              </a:defRPr>
-            </a:pPr>
-            <a:r>
-              <a:t>■ Project Accomplishments</a:t>
-            </a:r>
-          </a:p>
-          <a:p>
-            <a:pPr>
-              <a:defRPr sz="1300">
-                <a:solidFill>
-                  <a:srgbClr val="475569"/>
-                </a:solidFill>
-              </a:defRPr>
-            </a:pPr>
-            <a:r>
-              <a:t>Engineered a robust, end-to-end prototype validating the initial abstract with reproducible experiments.</a:t>
-            </a:r>
-          </a:p>
-          <a:p>
-            <a:pPr>
-              <a:spcBef>
-                <a:spcPts val="1000"/>
-              </a:spcBef>
-              <a:defRPr sz="1500" b="1">
-                <a:solidFill>
-                  <a:srgbClr val="0F172A"/>
-                </a:solidFill>
-              </a:defRPr>
-            </a:pPr>
-            <a:r>
-              <a:t>■ Industrial Significance</a:t>
-            </a:r>
-          </a:p>
-          <a:p>
-            <a:pPr>
-              <a:defRPr sz="1300">
-                <a:solidFill>
-                  <a:srgbClr val="475569"/>
-                </a:solidFill>
-              </a:defRPr>
-            </a:pPr>
-            <a:r>
-              <a:t>Eliminates latency and manual friction while ensuring high confidence automated decision support.</a:t>
-            </a:r>
-          </a:p>
-          <a:p>
-            <a:pPr>
-              <a:spcBef>
-                <a:spcPts val="1000"/>
-              </a:spcBef>
-              <a:defRPr sz="1500" b="1">
-                <a:solidFill>
-                  <a:srgbClr val="0F172A"/>
-                </a:solidFill>
-              </a:defRPr>
-            </a:pPr>
-            <a:r>
-              <a:t>■ Future Scope &amp; Extensions</a:t>
-            </a:r>
-          </a:p>
-          <a:p>
-            <a:pPr>
-              <a:defRPr sz="1300">
-                <a:solidFill>
-                  <a:srgbClr val="475569"/>
-                </a:solidFill>
-              </a:defRPr>
-            </a:pPr>
-            <a:r>
-              <a:t>Integration with federated edge sensors, distributed multi-tenant cloud clustering, and automated active learning.</a:t>
+              <a:defRPr b="1" sz="1300">
+                <a:solidFill>
+                  <a:srgbClr val="06B6D4"/>
+                </a:solidFill>
+              </a:defRPr>
+            </a:pPr>
+            <a:r>
+              <a:t>PORTAL OVERVIEW</a:t>
+            </a:r>
+          </a:p>
+          <a:p>
+            <a:pPr>
+              <a:defRPr sz="1200">
+                <a:solidFill>
+                  <a:srgbClr val="F8FAFC"/>
+                </a:solidFill>
+              </a:defRPr>
+            </a:pPr>
+            <a:r>
+              <a:t>• Modern responsive clinical portal running on Port 5006.</a:t>
+            </a:r>
+            <a:br/>
+            <a:r>
+              <a:t>• Direct navigation between Home, Assessment, History, Reports, and Guidelines.</a:t>
+            </a:r>
+            <a:br/>
+            <a:r>
+              <a:t>• Active patient statistics, normative baselines, and instant sample test presets.</a:t>
+            </a:r>
+          </a:p>
+        </p:txBody>
+      </p:sp>
+    </p:spTree>
+  </p:cSld>
+  <p:clrMapOvr>
+    <a:masterClrMapping/>
+  </p:clrMapOvr>
+</p:sld>
+</file>
+
+<file path=ppt/slides/slide9.xml><?xml version="1.0" encoding="utf-8"?>
+<p:sld xmlns:a="http://schemas.openxmlformats.org/drawingml/2006/main" xmlns:p="http://schemas.openxmlformats.org/presentationml/2006/main" xmlns:r="http://schemas.openxmlformats.org/officeDocument/2006/relationships">
+  <p:cSld>
+    <p:spTree>
+      <p:nvGrpSpPr>
+        <p:cNvPr id="1" name=""/>
+        <p:cNvGrpSpPr/>
+        <p:nvPr/>
+      </p:nvGrpSpPr>
+      <p:grpSpPr/>
+      <p:sp>
+        <p:nvSpPr>
+          <p:cNvPr id="2" name="Rectangle 1"/>
+          <p:cNvSpPr/>
+          <p:nvPr/>
+        </p:nvSpPr>
+        <p:spPr>
+          <a:xfrm>
+            <a:off x="0" y="0"/>
+            <a:ext cx="12191695" cy="6858000"/>
+          </a:xfrm>
+          <a:prstGeom prst="rect">
+            <a:avLst/>
+          </a:prstGeom>
+          <a:solidFill>
+            <a:srgbClr val="0F172A"/>
+          </a:solidFill>
+          <a:ln>
+            <a:noFill/>
+          </a:ln>
+        </p:spPr>
+        <p:style>
+          <a:lnRef idx="1">
+            <a:schemeClr val="accent1"/>
+          </a:lnRef>
+          <a:fillRef idx="3">
+            <a:schemeClr val="accent1"/>
+          </a:fillRef>
+          <a:effectRef idx="2">
+            <a:schemeClr val="accent1"/>
+          </a:effectRef>
+          <a:fontRef idx="minor">
+            <a:schemeClr val="lt1"/>
+          </a:fontRef>
+        </p:style>
+        <p:txBody>
+          <a:bodyPr rtlCol="0" anchor="ctr"/>
+          <a:lstStyle/>
+          <a:p>
+            <a:pPr algn="ctr"/>
+          </a:p>
+        </p:txBody>
+      </p:sp>
+      <p:sp>
+        <p:nvSpPr>
+          <p:cNvPr id="3" name="TextBox 2"/>
+          <p:cNvSpPr txBox="1"/>
+          <p:nvPr/>
+        </p:nvSpPr>
+        <p:spPr>
+          <a:xfrm>
+            <a:off x="731520" y="457200"/>
+            <a:ext cx="10728655" cy="1005840"/>
+          </a:xfrm>
+          <a:prstGeom prst="rect">
+            <a:avLst/>
+          </a:prstGeom>
+          <a:noFill/>
+        </p:spPr>
+        <p:txBody>
+          <a:bodyPr wrap="square">
+            <a:spAutoFit/>
+          </a:bodyPr>
+          <a:lstStyle/>
+          <a:p>
+            <a:pPr>
+              <a:defRPr sz="1100" b="1">
+                <a:solidFill>
+                  <a:srgbClr val="06B6D4"/>
+                </a:solidFill>
+              </a:defRPr>
+            </a:pPr>
+            <a:r>
+              <a:t>PEDIATRIC BIOMECHANICS &amp; APPLIED MACHINE LEARNING</a:t>
+            </a:r>
+          </a:p>
+          <a:p>
+            <a:pPr>
+              <a:defRPr sz="2200" b="1">
+                <a:solidFill>
+                  <a:srgbClr val="F8FAFC"/>
+                </a:solidFill>
+              </a:defRPr>
+            </a:pPr>
+            <a:r>
+              <a:t>Biometric &amp; Kinetic Gait Assessment Input Form</a:t>
+            </a:r>
+          </a:p>
+        </p:txBody>
+      </p:sp>
+      <p:pic>
+        <p:nvPicPr>
+          <p:cNvPr id="4" name="Picture 3" descr="02_gait_assessment_input.png"/>
+          <p:cNvPicPr>
+            <a:picLocks noChangeAspect="1"/>
+          </p:cNvPicPr>
+          <p:nvPr/>
+        </p:nvPicPr>
+        <p:blipFill>
+          <a:blip r:embed="rId2"/>
+          <a:stretch>
+            <a:fillRect/>
+          </a:stretch>
+        </p:blipFill>
+        <p:spPr>
+          <a:xfrm>
+            <a:off x="731520" y="1645920"/>
+            <a:ext cx="6583680" cy="4114800"/>
+          </a:xfrm>
+          <a:prstGeom prst="rect">
+            <a:avLst/>
+          </a:prstGeom>
+        </p:spPr>
+      </p:pic>
+      <p:sp>
+        <p:nvSpPr>
+          <p:cNvPr id="5" name="TextBox 4"/>
+          <p:cNvSpPr txBox="1"/>
+          <p:nvPr/>
+        </p:nvSpPr>
+        <p:spPr>
+          <a:xfrm>
+            <a:off x="7589520" y="1645920"/>
+            <a:ext cx="3840480" cy="4572000"/>
+          </a:xfrm>
+          <a:prstGeom prst="rect">
+            <a:avLst/>
+          </a:prstGeom>
+          <a:noFill/>
+        </p:spPr>
+        <p:txBody>
+          <a:bodyPr wrap="square">
+            <a:spAutoFit/>
+          </a:bodyPr>
+          <a:lstStyle/>
+          <a:p>
+            <a:pPr>
+              <a:defRPr b="1" sz="1300">
+                <a:solidFill>
+                  <a:srgbClr val="06B6D4"/>
+                </a:solidFill>
+              </a:defRPr>
+            </a:pPr>
+            <a:r>
+              <a:t>INPUT SPECIFICATIONS</a:t>
+            </a:r>
+          </a:p>
+          <a:p>
+            <a:pPr>
+              <a:defRPr sz="1200">
+                <a:solidFill>
+                  <a:srgbClr val="F8FAFC"/>
+                </a:solidFill>
+              </a:defRPr>
+            </a:pPr>
+            <a:r>
+              <a:t>• Captures child demographics (Child ID, Age, Gender).</a:t>
+            </a:r>
+            <a:br/>
+            <a:r>
+              <a:t>• Biomechanical parameters: Heel &amp; Toe Pressure (kPa), Foot Tilt Angle (°), Step Duration (s), Stride Length (cm), Walking Speed (m/s).</a:t>
+            </a:r>
+            <a:br/>
+            <a:r>
+              <a:t>• One-click sample presets for Diplegic, Hemiplegic, and Normal gaits.</a:t>
             </a:r>
           </a:p>
         </p:txBody>

</xml_diff>